<commit_message>
Refactor project initiation workflow and registration process
</commit_message>
<xml_diff>
--- a/img/project-lifecycle.pptx
+++ b/img/project-lifecycle.pptx
@@ -2,18 +2,18 @@
 <file path=ppt/presentation.xml><?xml version="1.0" encoding="utf-8"?>
 <p:presentation xmlns:a="http://schemas.openxmlformats.org/drawingml/2006/main" xmlns:r="http://schemas.openxmlformats.org/officeDocument/2006/relationships" xmlns:p="http://schemas.openxmlformats.org/presentationml/2006/main" saveSubsetFonts="1" autoCompressPictures="0">
   <p:sldMasterIdLst>
-    <p:sldMasterId id="2147483648" r:id="rId1"/>
+    <p:sldMasterId id="2147483720" r:id="rId1"/>
   </p:sldMasterIdLst>
   <p:sldIdLst>
     <p:sldId id="256" r:id="rId2"/>
   </p:sldIdLst>
-  <p:sldSz cx="12192000" cy="6858000"/>
+  <p:sldSz cx="5400675" cy="5040313"/>
   <p:notesSz cx="6858000" cy="9144000"/>
   <p:defaultTextStyle>
     <a:defPPr>
-      <a:defRPr lang="en-NL"/>
+      <a:defRPr lang="en-US"/>
     </a:defPPr>
-    <a:lvl1pPr marL="0" algn="l" defTabSz="914400" rtl="0" eaLnBrk="1" latinLnBrk="0" hangingPunct="1">
+    <a:lvl1pPr marL="0" algn="l" defTabSz="457200" rtl="0" eaLnBrk="1" latinLnBrk="0" hangingPunct="1">
       <a:defRPr sz="1800" kern="1200">
         <a:solidFill>
           <a:schemeClr val="tx1"/>
@@ -23,7 +23,7 @@
         <a:cs typeface="+mn-cs"/>
       </a:defRPr>
     </a:lvl1pPr>
-    <a:lvl2pPr marL="457200" algn="l" defTabSz="914400" rtl="0" eaLnBrk="1" latinLnBrk="0" hangingPunct="1">
+    <a:lvl2pPr marL="457200" algn="l" defTabSz="457200" rtl="0" eaLnBrk="1" latinLnBrk="0" hangingPunct="1">
       <a:defRPr sz="1800" kern="1200">
         <a:solidFill>
           <a:schemeClr val="tx1"/>
@@ -33,7 +33,7 @@
         <a:cs typeface="+mn-cs"/>
       </a:defRPr>
     </a:lvl2pPr>
-    <a:lvl3pPr marL="914400" algn="l" defTabSz="914400" rtl="0" eaLnBrk="1" latinLnBrk="0" hangingPunct="1">
+    <a:lvl3pPr marL="914400" algn="l" defTabSz="457200" rtl="0" eaLnBrk="1" latinLnBrk="0" hangingPunct="1">
       <a:defRPr sz="1800" kern="1200">
         <a:solidFill>
           <a:schemeClr val="tx1"/>
@@ -43,7 +43,7 @@
         <a:cs typeface="+mn-cs"/>
       </a:defRPr>
     </a:lvl3pPr>
-    <a:lvl4pPr marL="1371600" algn="l" defTabSz="914400" rtl="0" eaLnBrk="1" latinLnBrk="0" hangingPunct="1">
+    <a:lvl4pPr marL="1371600" algn="l" defTabSz="457200" rtl="0" eaLnBrk="1" latinLnBrk="0" hangingPunct="1">
       <a:defRPr sz="1800" kern="1200">
         <a:solidFill>
           <a:schemeClr val="tx1"/>
@@ -53,7 +53,7 @@
         <a:cs typeface="+mn-cs"/>
       </a:defRPr>
     </a:lvl4pPr>
-    <a:lvl5pPr marL="1828800" algn="l" defTabSz="914400" rtl="0" eaLnBrk="1" latinLnBrk="0" hangingPunct="1">
+    <a:lvl5pPr marL="1828800" algn="l" defTabSz="457200" rtl="0" eaLnBrk="1" latinLnBrk="0" hangingPunct="1">
       <a:defRPr sz="1800" kern="1200">
         <a:solidFill>
           <a:schemeClr val="tx1"/>
@@ -63,7 +63,7 @@
         <a:cs typeface="+mn-cs"/>
       </a:defRPr>
     </a:lvl5pPr>
-    <a:lvl6pPr marL="2286000" algn="l" defTabSz="914400" rtl="0" eaLnBrk="1" latinLnBrk="0" hangingPunct="1">
+    <a:lvl6pPr marL="2286000" algn="l" defTabSz="457200" rtl="0" eaLnBrk="1" latinLnBrk="0" hangingPunct="1">
       <a:defRPr sz="1800" kern="1200">
         <a:solidFill>
           <a:schemeClr val="tx1"/>
@@ -73,7 +73,7 @@
         <a:cs typeface="+mn-cs"/>
       </a:defRPr>
     </a:lvl6pPr>
-    <a:lvl7pPr marL="2743200" algn="l" defTabSz="914400" rtl="0" eaLnBrk="1" latinLnBrk="0" hangingPunct="1">
+    <a:lvl7pPr marL="2743200" algn="l" defTabSz="457200" rtl="0" eaLnBrk="1" latinLnBrk="0" hangingPunct="1">
       <a:defRPr sz="1800" kern="1200">
         <a:solidFill>
           <a:schemeClr val="tx1"/>
@@ -83,7 +83,7 @@
         <a:cs typeface="+mn-cs"/>
       </a:defRPr>
     </a:lvl7pPr>
-    <a:lvl8pPr marL="3200400" algn="l" defTabSz="914400" rtl="0" eaLnBrk="1" latinLnBrk="0" hangingPunct="1">
+    <a:lvl8pPr marL="3200400" algn="l" defTabSz="457200" rtl="0" eaLnBrk="1" latinLnBrk="0" hangingPunct="1">
       <a:defRPr sz="1800" kern="1200">
         <a:solidFill>
           <a:schemeClr val="tx1"/>
@@ -93,7 +93,7 @@
         <a:cs typeface="+mn-cs"/>
       </a:defRPr>
     </a:lvl8pPr>
-    <a:lvl9pPr marL="3657600" algn="l" defTabSz="914400" rtl="0" eaLnBrk="1" latinLnBrk="0" hangingPunct="1">
+    <a:lvl9pPr marL="3657600" algn="l" defTabSz="457200" rtl="0" eaLnBrk="1" latinLnBrk="0" hangingPunct="1">
       <a:defRPr sz="1800" kern="1200">
         <a:solidFill>
           <a:schemeClr val="tx1"/>
@@ -104,7 +104,49 @@
       </a:defRPr>
     </a:lvl9pPr>
   </p:defaultTextStyle>
+  <p:extLst>
+    <p:ext uri="{EFAFB233-063F-42B5-8137-9DF3F51BA10A}">
+      <p15:sldGuideLst xmlns:p15="http://schemas.microsoft.com/office/powerpoint/2012/main"/>
+    </p:ext>
+  </p:extLst>
 </p:presentation>
+</file>
+
+<file path=ppt/revisionInfo.xml><?xml version="1.0" encoding="utf-8"?>
+<p1510:revInfo xmlns:a="http://schemas.openxmlformats.org/drawingml/2006/main" xmlns:r="http://schemas.openxmlformats.org/officeDocument/2006/relationships" xmlns:p1510="http://schemas.microsoft.com/office/powerpoint/2015/10/main">
+  <p1510:revLst>
+    <p1510:client id="{91A79CE5-139E-C641-AD3E-09C51B89859F}" v="8" dt="2026-07-27T11:05:58.472"/>
+  </p1510:revLst>
+</p1510:revInfo>
+</file>
+
+<file path=ppt/changesInfos/changesInfo1.xml><?xml version="1.0" encoding="utf-8"?>
+<pc:chgInfo xmlns:a="http://schemas.openxmlformats.org/drawingml/2006/main" xmlns:r="http://schemas.openxmlformats.org/officeDocument/2006/relationships" xmlns:ac="http://schemas.microsoft.com/office/drawing/2013/main/command" xmlns:pc="http://schemas.microsoft.com/office/powerpoint/2013/main/command">
+  <pc:docChgLst>
+    <pc:chgData name="Pablo Lopez-Tarifa" userId="cee9dd59-b929-45f6-b309-b6095fcca39b" providerId="ADAL" clId="{7DBB9EE6-AD92-5BF3-945A-E5C30DB93B8E}"/>
+    <pc:docChg chg="modSld">
+      <pc:chgData name="Pablo Lopez-Tarifa" userId="cee9dd59-b929-45f6-b309-b6095fcca39b" providerId="ADAL" clId="{7DBB9EE6-AD92-5BF3-945A-E5C30DB93B8E}" dt="2026-07-28T07:55:51.823" v="19" actId="20577"/>
+      <pc:docMkLst>
+        <pc:docMk/>
+      </pc:docMkLst>
+      <pc:sldChg chg="modSp mod">
+        <pc:chgData name="Pablo Lopez-Tarifa" userId="cee9dd59-b929-45f6-b309-b6095fcca39b" providerId="ADAL" clId="{7DBB9EE6-AD92-5BF3-945A-E5C30DB93B8E}" dt="2026-07-28T07:55:51.823" v="19" actId="20577"/>
+        <pc:sldMkLst>
+          <pc:docMk/>
+          <pc:sldMk cId="2890507671" sldId="256"/>
+        </pc:sldMkLst>
+        <pc:spChg chg="mod">
+          <ac:chgData name="Pablo Lopez-Tarifa" userId="cee9dd59-b929-45f6-b309-b6095fcca39b" providerId="ADAL" clId="{7DBB9EE6-AD92-5BF3-945A-E5C30DB93B8E}" dt="2026-07-28T07:55:51.823" v="19" actId="20577"/>
+          <ac:spMkLst>
+            <pc:docMk/>
+            <pc:sldMk cId="2890507671" sldId="256"/>
+            <ac:spMk id="5" creationId="{9BF3D0E5-1B02-C86B-7FEE-054CC6955DEA}"/>
+          </ac:spMkLst>
+        </pc:spChg>
+      </pc:sldChg>
+    </pc:docChg>
+  </pc:docChgLst>
+</pc:chgInfo>
 </file>
 
 <file path=ppt/slideLayouts/slideLayout1.xml><?xml version="1.0" encoding="utf-8"?>
@@ -126,13 +168,7 @@
       </p:grpSpPr>
       <p:sp>
         <p:nvSpPr>
-          <p:cNvPr id="2" name="Title 1">
-            <a:extLst>
-              <a:ext uri="{FF2B5EF4-FFF2-40B4-BE49-F238E27FC236}">
-                <a16:creationId xmlns:a16="http://schemas.microsoft.com/office/drawing/2014/main" id="{59FEBD10-3479-D86D-8CB8-8D17356DE80B}"/>
-              </a:ext>
-            </a:extLst>
-          </p:cNvPr>
+          <p:cNvPr id="2" name="Title 1"/>
           <p:cNvSpPr>
             <a:spLocks noGrp="1"/>
           </p:cNvSpPr>
@@ -142,15 +178,15 @@
         </p:nvSpPr>
         <p:spPr>
           <a:xfrm>
-            <a:off x="1524000" y="1122363"/>
-            <a:ext cx="9144000" cy="2387600"/>
+            <a:off x="405051" y="824885"/>
+            <a:ext cx="4590574" cy="1754776"/>
           </a:xfrm>
         </p:spPr>
         <p:txBody>
           <a:bodyPr anchor="b"/>
           <a:lstStyle>
             <a:lvl1pPr algn="ctr">
-              <a:defRPr sz="6000"/>
+              <a:defRPr sz="3544"/>
             </a:lvl1pPr>
           </a:lstStyle>
           <a:p>
@@ -158,19 +194,13 @@
               <a:rPr lang="en-GB"/>
               <a:t>Click to edit Master title style</a:t>
             </a:r>
-            <a:endParaRPr lang="en-NL"/>
-          </a:p>
-        </p:txBody>
-      </p:sp>
-      <p:sp>
-        <p:nvSpPr>
-          <p:cNvPr id="3" name="Subtitle 2">
-            <a:extLst>
-              <a:ext uri="{FF2B5EF4-FFF2-40B4-BE49-F238E27FC236}">
-                <a16:creationId xmlns:a16="http://schemas.microsoft.com/office/drawing/2014/main" id="{4759F270-81A0-4DB0-1442-964D498BD785}"/>
-              </a:ext>
-            </a:extLst>
-          </p:cNvPr>
+            <a:endParaRPr lang="en-US" dirty="0"/>
+          </a:p>
+        </p:txBody>
+      </p:sp>
+      <p:sp>
+        <p:nvSpPr>
+          <p:cNvPr id="3" name="Subtitle 2"/>
           <p:cNvSpPr>
             <a:spLocks noGrp="1"/>
           </p:cNvSpPr>
@@ -180,8 +210,8 @@
         </p:nvSpPr>
         <p:spPr>
           <a:xfrm>
-            <a:off x="1524000" y="3602038"/>
-            <a:ext cx="9144000" cy="1655762"/>
+            <a:off x="675085" y="2647331"/>
+            <a:ext cx="4050506" cy="1216909"/>
           </a:xfrm>
         </p:spPr>
         <p:txBody>
@@ -189,39 +219,39 @@
           <a:lstStyle>
             <a:lvl1pPr marL="0" indent="0" algn="ctr">
               <a:buNone/>
-              <a:defRPr sz="2400"/>
+              <a:defRPr sz="1417"/>
             </a:lvl1pPr>
-            <a:lvl2pPr marL="457200" indent="0" algn="ctr">
-              <a:buNone/>
-              <a:defRPr sz="2000"/>
+            <a:lvl2pPr marL="270022" indent="0" algn="ctr">
+              <a:buNone/>
+              <a:defRPr sz="1181"/>
             </a:lvl2pPr>
-            <a:lvl3pPr marL="914400" indent="0" algn="ctr">
-              <a:buNone/>
-              <a:defRPr sz="1800"/>
+            <a:lvl3pPr marL="540045" indent="0" algn="ctr">
+              <a:buNone/>
+              <a:defRPr sz="1063"/>
             </a:lvl3pPr>
-            <a:lvl4pPr marL="1371600" indent="0" algn="ctr">
-              <a:buNone/>
-              <a:defRPr sz="1600"/>
+            <a:lvl4pPr marL="810067" indent="0" algn="ctr">
+              <a:buNone/>
+              <a:defRPr sz="945"/>
             </a:lvl4pPr>
-            <a:lvl5pPr marL="1828800" indent="0" algn="ctr">
-              <a:buNone/>
-              <a:defRPr sz="1600"/>
+            <a:lvl5pPr marL="1080089" indent="0" algn="ctr">
+              <a:buNone/>
+              <a:defRPr sz="945"/>
             </a:lvl5pPr>
-            <a:lvl6pPr marL="2286000" indent="0" algn="ctr">
-              <a:buNone/>
-              <a:defRPr sz="1600"/>
+            <a:lvl6pPr marL="1350112" indent="0" algn="ctr">
+              <a:buNone/>
+              <a:defRPr sz="945"/>
             </a:lvl6pPr>
-            <a:lvl7pPr marL="2743200" indent="0" algn="ctr">
-              <a:buNone/>
-              <a:defRPr sz="1600"/>
+            <a:lvl7pPr marL="1620134" indent="0" algn="ctr">
+              <a:buNone/>
+              <a:defRPr sz="945"/>
             </a:lvl7pPr>
-            <a:lvl8pPr marL="3200400" indent="0" algn="ctr">
-              <a:buNone/>
-              <a:defRPr sz="1600"/>
+            <a:lvl8pPr marL="1890156" indent="0" algn="ctr">
+              <a:buNone/>
+              <a:defRPr sz="945"/>
             </a:lvl8pPr>
-            <a:lvl9pPr marL="3657600" indent="0" algn="ctr">
-              <a:buNone/>
-              <a:defRPr sz="1600"/>
+            <a:lvl9pPr marL="2160179" indent="0" algn="ctr">
+              <a:buNone/>
+              <a:defRPr sz="945"/>
             </a:lvl9pPr>
           </a:lstStyle>
           <a:p>
@@ -229,19 +259,13 @@
               <a:rPr lang="en-GB"/>
               <a:t>Click to edit Master subtitle style</a:t>
             </a:r>
-            <a:endParaRPr lang="en-NL"/>
-          </a:p>
-        </p:txBody>
-      </p:sp>
-      <p:sp>
-        <p:nvSpPr>
-          <p:cNvPr id="4" name="Date Placeholder 3">
-            <a:extLst>
-              <a:ext uri="{FF2B5EF4-FFF2-40B4-BE49-F238E27FC236}">
-                <a16:creationId xmlns:a16="http://schemas.microsoft.com/office/drawing/2014/main" id="{4010F167-2A14-53FB-B7B6-64BAEFA5B8F9}"/>
-              </a:ext>
-            </a:extLst>
-          </p:cNvPr>
+            <a:endParaRPr lang="en-US" dirty="0"/>
+          </a:p>
+        </p:txBody>
+      </p:sp>
+      <p:sp>
+        <p:nvSpPr>
+          <p:cNvPr id="4" name="Date Placeholder 3"/>
           <p:cNvSpPr>
             <a:spLocks noGrp="1"/>
           </p:cNvSpPr>
@@ -256,7 +280,7 @@
           <a:p>
             <a:fld id="{02A1A179-2826-B94E-B378-7E45598DB11F}" type="datetimeFigureOut">
               <a:rPr lang="en-NL" smtClean="0"/>
-              <a:t>27/07/2026</a:t>
+              <a:t>28/07/2026</a:t>
             </a:fld>
             <a:endParaRPr lang="en-NL"/>
           </a:p>
@@ -264,13 +288,7 @@
       </p:sp>
       <p:sp>
         <p:nvSpPr>
-          <p:cNvPr id="5" name="Footer Placeholder 4">
-            <a:extLst>
-              <a:ext uri="{FF2B5EF4-FFF2-40B4-BE49-F238E27FC236}">
-                <a16:creationId xmlns:a16="http://schemas.microsoft.com/office/drawing/2014/main" id="{F0B5E668-6124-E5A1-2279-8F8E2CA4C24C}"/>
-              </a:ext>
-            </a:extLst>
-          </p:cNvPr>
+          <p:cNvPr id="5" name="Footer Placeholder 4"/>
           <p:cNvSpPr>
             <a:spLocks noGrp="1"/>
           </p:cNvSpPr>
@@ -289,13 +307,7 @@
       </p:sp>
       <p:sp>
         <p:nvSpPr>
-          <p:cNvPr id="6" name="Slide Number Placeholder 5">
-            <a:extLst>
-              <a:ext uri="{FF2B5EF4-FFF2-40B4-BE49-F238E27FC236}">
-                <a16:creationId xmlns:a16="http://schemas.microsoft.com/office/drawing/2014/main" id="{8647C48E-24FB-C565-0D4C-A978FD891982}"/>
-              </a:ext>
-            </a:extLst>
-          </p:cNvPr>
+          <p:cNvPr id="6" name="Slide Number Placeholder 5"/>
           <p:cNvSpPr>
             <a:spLocks noGrp="1"/>
           </p:cNvSpPr>
@@ -319,7 +331,7 @@
     </p:spTree>
     <p:extLst>
       <p:ext uri="{BB962C8B-B14F-4D97-AF65-F5344CB8AC3E}">
-        <p14:creationId xmlns:p14="http://schemas.microsoft.com/office/powerpoint/2010/main" val="724977683"/>
+        <p14:creationId xmlns:p14="http://schemas.microsoft.com/office/powerpoint/2010/main" val="3791043884"/>
       </p:ext>
     </p:extLst>
   </p:cSld>
@@ -348,13 +360,7 @@
       </p:grpSpPr>
       <p:sp>
         <p:nvSpPr>
-          <p:cNvPr id="2" name="Title 1">
-            <a:extLst>
-              <a:ext uri="{FF2B5EF4-FFF2-40B4-BE49-F238E27FC236}">
-                <a16:creationId xmlns:a16="http://schemas.microsoft.com/office/drawing/2014/main" id="{594AF2B0-64FC-A173-F79D-045BD1EE01B0}"/>
-              </a:ext>
-            </a:extLst>
-          </p:cNvPr>
+          <p:cNvPr id="2" name="Title 1"/>
           <p:cNvSpPr>
             <a:spLocks noGrp="1"/>
           </p:cNvSpPr>
@@ -371,19 +377,13 @@
               <a:rPr lang="en-GB"/>
               <a:t>Click to edit Master title style</a:t>
             </a:r>
-            <a:endParaRPr lang="en-NL"/>
-          </a:p>
-        </p:txBody>
-      </p:sp>
-      <p:sp>
-        <p:nvSpPr>
-          <p:cNvPr id="3" name="Vertical Text Placeholder 2">
-            <a:extLst>
-              <a:ext uri="{FF2B5EF4-FFF2-40B4-BE49-F238E27FC236}">
-                <a16:creationId xmlns:a16="http://schemas.microsoft.com/office/drawing/2014/main" id="{092164F8-74B6-A9AB-F129-AEABF8780BD5}"/>
-              </a:ext>
-            </a:extLst>
-          </p:cNvPr>
+            <a:endParaRPr lang="en-US" dirty="0"/>
+          </a:p>
+        </p:txBody>
+      </p:sp>
+      <p:sp>
+        <p:nvSpPr>
+          <p:cNvPr id="3" name="Vertical Text Placeholder 2"/>
           <p:cNvSpPr>
             <a:spLocks noGrp="1"/>
           </p:cNvSpPr>
@@ -429,19 +429,13 @@
               <a:rPr lang="en-GB"/>
               <a:t>Fifth level</a:t>
             </a:r>
-            <a:endParaRPr lang="en-NL"/>
-          </a:p>
-        </p:txBody>
-      </p:sp>
-      <p:sp>
-        <p:nvSpPr>
-          <p:cNvPr id="4" name="Date Placeholder 3">
-            <a:extLst>
-              <a:ext uri="{FF2B5EF4-FFF2-40B4-BE49-F238E27FC236}">
-                <a16:creationId xmlns:a16="http://schemas.microsoft.com/office/drawing/2014/main" id="{9E199819-5AE9-1389-AA2D-823AA24752A5}"/>
-              </a:ext>
-            </a:extLst>
-          </p:cNvPr>
+            <a:endParaRPr lang="en-US" dirty="0"/>
+          </a:p>
+        </p:txBody>
+      </p:sp>
+      <p:sp>
+        <p:nvSpPr>
+          <p:cNvPr id="4" name="Date Placeholder 3"/>
           <p:cNvSpPr>
             <a:spLocks noGrp="1"/>
           </p:cNvSpPr>
@@ -456,7 +450,7 @@
           <a:p>
             <a:fld id="{02A1A179-2826-B94E-B378-7E45598DB11F}" type="datetimeFigureOut">
               <a:rPr lang="en-NL" smtClean="0"/>
-              <a:t>27/07/2026</a:t>
+              <a:t>28/07/2026</a:t>
             </a:fld>
             <a:endParaRPr lang="en-NL"/>
           </a:p>
@@ -464,13 +458,7 @@
       </p:sp>
       <p:sp>
         <p:nvSpPr>
-          <p:cNvPr id="5" name="Footer Placeholder 4">
-            <a:extLst>
-              <a:ext uri="{FF2B5EF4-FFF2-40B4-BE49-F238E27FC236}">
-                <a16:creationId xmlns:a16="http://schemas.microsoft.com/office/drawing/2014/main" id="{F1131932-8458-8E86-C99F-F4EB18989A6E}"/>
-              </a:ext>
-            </a:extLst>
-          </p:cNvPr>
+          <p:cNvPr id="5" name="Footer Placeholder 4"/>
           <p:cNvSpPr>
             <a:spLocks noGrp="1"/>
           </p:cNvSpPr>
@@ -489,13 +477,7 @@
       </p:sp>
       <p:sp>
         <p:nvSpPr>
-          <p:cNvPr id="6" name="Slide Number Placeholder 5">
-            <a:extLst>
-              <a:ext uri="{FF2B5EF4-FFF2-40B4-BE49-F238E27FC236}">
-                <a16:creationId xmlns:a16="http://schemas.microsoft.com/office/drawing/2014/main" id="{45334C08-C272-A34D-E92E-8ED22BC0A9E4}"/>
-              </a:ext>
-            </a:extLst>
-          </p:cNvPr>
+          <p:cNvPr id="6" name="Slide Number Placeholder 5"/>
           <p:cNvSpPr>
             <a:spLocks noGrp="1"/>
           </p:cNvSpPr>
@@ -519,7 +501,7 @@
     </p:spTree>
     <p:extLst>
       <p:ext uri="{BB962C8B-B14F-4D97-AF65-F5344CB8AC3E}">
-        <p14:creationId xmlns:p14="http://schemas.microsoft.com/office/powerpoint/2010/main" val="2993622663"/>
+        <p14:creationId xmlns:p14="http://schemas.microsoft.com/office/powerpoint/2010/main" val="4008507643"/>
       </p:ext>
     </p:extLst>
   </p:cSld>
@@ -548,13 +530,7 @@
       </p:grpSpPr>
       <p:sp>
         <p:nvSpPr>
-          <p:cNvPr id="2" name="Vertical Title 1">
-            <a:extLst>
-              <a:ext uri="{FF2B5EF4-FFF2-40B4-BE49-F238E27FC236}">
-                <a16:creationId xmlns:a16="http://schemas.microsoft.com/office/drawing/2014/main" id="{79904305-28CE-0A5C-60F4-ACCEA23315C0}"/>
-              </a:ext>
-            </a:extLst>
-          </p:cNvPr>
+          <p:cNvPr id="2" name="Vertical Title 1"/>
           <p:cNvSpPr>
             <a:spLocks noGrp="1"/>
           </p:cNvSpPr>
@@ -564,8 +540,8 @@
         </p:nvSpPr>
         <p:spPr>
           <a:xfrm>
-            <a:off x="8724900" y="365125"/>
-            <a:ext cx="2628900" cy="5811838"/>
+            <a:off x="3864858" y="268350"/>
+            <a:ext cx="1164521" cy="4271432"/>
           </a:xfrm>
         </p:spPr>
         <p:txBody>
@@ -576,19 +552,13 @@
               <a:rPr lang="en-GB"/>
               <a:t>Click to edit Master title style</a:t>
             </a:r>
-            <a:endParaRPr lang="en-NL"/>
-          </a:p>
-        </p:txBody>
-      </p:sp>
-      <p:sp>
-        <p:nvSpPr>
-          <p:cNvPr id="3" name="Vertical Text Placeholder 2">
-            <a:extLst>
-              <a:ext uri="{FF2B5EF4-FFF2-40B4-BE49-F238E27FC236}">
-                <a16:creationId xmlns:a16="http://schemas.microsoft.com/office/drawing/2014/main" id="{B5F7925A-7C8F-EE64-98AF-DA53DB284680}"/>
-              </a:ext>
-            </a:extLst>
-          </p:cNvPr>
+            <a:endParaRPr lang="en-US" dirty="0"/>
+          </a:p>
+        </p:txBody>
+      </p:sp>
+      <p:sp>
+        <p:nvSpPr>
+          <p:cNvPr id="3" name="Vertical Text Placeholder 2"/>
           <p:cNvSpPr>
             <a:spLocks noGrp="1"/>
           </p:cNvSpPr>
@@ -598,8 +568,8 @@
         </p:nvSpPr>
         <p:spPr>
           <a:xfrm>
-            <a:off x="838200" y="365125"/>
-            <a:ext cx="7734300" cy="5811838"/>
+            <a:off x="371297" y="268350"/>
+            <a:ext cx="3426053" cy="4271432"/>
           </a:xfrm>
         </p:spPr>
         <p:txBody>
@@ -639,19 +609,13 @@
               <a:rPr lang="en-GB"/>
               <a:t>Fifth level</a:t>
             </a:r>
-            <a:endParaRPr lang="en-NL"/>
-          </a:p>
-        </p:txBody>
-      </p:sp>
-      <p:sp>
-        <p:nvSpPr>
-          <p:cNvPr id="4" name="Date Placeholder 3">
-            <a:extLst>
-              <a:ext uri="{FF2B5EF4-FFF2-40B4-BE49-F238E27FC236}">
-                <a16:creationId xmlns:a16="http://schemas.microsoft.com/office/drawing/2014/main" id="{E6684BF0-A9F1-686C-6C52-B24FE8A09D17}"/>
-              </a:ext>
-            </a:extLst>
-          </p:cNvPr>
+            <a:endParaRPr lang="en-US" dirty="0"/>
+          </a:p>
+        </p:txBody>
+      </p:sp>
+      <p:sp>
+        <p:nvSpPr>
+          <p:cNvPr id="4" name="Date Placeholder 3"/>
           <p:cNvSpPr>
             <a:spLocks noGrp="1"/>
           </p:cNvSpPr>
@@ -666,7 +630,7 @@
           <a:p>
             <a:fld id="{02A1A179-2826-B94E-B378-7E45598DB11F}" type="datetimeFigureOut">
               <a:rPr lang="en-NL" smtClean="0"/>
-              <a:t>27/07/2026</a:t>
+              <a:t>28/07/2026</a:t>
             </a:fld>
             <a:endParaRPr lang="en-NL"/>
           </a:p>
@@ -674,13 +638,7 @@
       </p:sp>
       <p:sp>
         <p:nvSpPr>
-          <p:cNvPr id="5" name="Footer Placeholder 4">
-            <a:extLst>
-              <a:ext uri="{FF2B5EF4-FFF2-40B4-BE49-F238E27FC236}">
-                <a16:creationId xmlns:a16="http://schemas.microsoft.com/office/drawing/2014/main" id="{5A5AA2A7-8EA4-3CD9-6BC5-72F3BD70D4D6}"/>
-              </a:ext>
-            </a:extLst>
-          </p:cNvPr>
+          <p:cNvPr id="5" name="Footer Placeholder 4"/>
           <p:cNvSpPr>
             <a:spLocks noGrp="1"/>
           </p:cNvSpPr>
@@ -699,13 +657,7 @@
       </p:sp>
       <p:sp>
         <p:nvSpPr>
-          <p:cNvPr id="6" name="Slide Number Placeholder 5">
-            <a:extLst>
-              <a:ext uri="{FF2B5EF4-FFF2-40B4-BE49-F238E27FC236}">
-                <a16:creationId xmlns:a16="http://schemas.microsoft.com/office/drawing/2014/main" id="{3CADA45E-FD6F-4E70-ADED-979E061D5DAF}"/>
-              </a:ext>
-            </a:extLst>
-          </p:cNvPr>
+          <p:cNvPr id="6" name="Slide Number Placeholder 5"/>
           <p:cNvSpPr>
             <a:spLocks noGrp="1"/>
           </p:cNvSpPr>
@@ -729,7 +681,7 @@
     </p:spTree>
     <p:extLst>
       <p:ext uri="{BB962C8B-B14F-4D97-AF65-F5344CB8AC3E}">
-        <p14:creationId xmlns:p14="http://schemas.microsoft.com/office/powerpoint/2010/main" val="2413574860"/>
+        <p14:creationId xmlns:p14="http://schemas.microsoft.com/office/powerpoint/2010/main" val="1477182381"/>
       </p:ext>
     </p:extLst>
   </p:cSld>
@@ -758,13 +710,7 @@
       </p:grpSpPr>
       <p:sp>
         <p:nvSpPr>
-          <p:cNvPr id="2" name="Title 1">
-            <a:extLst>
-              <a:ext uri="{FF2B5EF4-FFF2-40B4-BE49-F238E27FC236}">
-                <a16:creationId xmlns:a16="http://schemas.microsoft.com/office/drawing/2014/main" id="{6B7FA927-6C7B-6DCB-B43B-26640C5CAD16}"/>
-              </a:ext>
-            </a:extLst>
-          </p:cNvPr>
+          <p:cNvPr id="2" name="Title 1"/>
           <p:cNvSpPr>
             <a:spLocks noGrp="1"/>
           </p:cNvSpPr>
@@ -781,19 +727,13 @@
               <a:rPr lang="en-GB"/>
               <a:t>Click to edit Master title style</a:t>
             </a:r>
-            <a:endParaRPr lang="en-NL"/>
-          </a:p>
-        </p:txBody>
-      </p:sp>
-      <p:sp>
-        <p:nvSpPr>
-          <p:cNvPr id="3" name="Content Placeholder 2">
-            <a:extLst>
-              <a:ext uri="{FF2B5EF4-FFF2-40B4-BE49-F238E27FC236}">
-                <a16:creationId xmlns:a16="http://schemas.microsoft.com/office/drawing/2014/main" id="{1EE732BB-6CFE-6D2D-2789-E220EF0C3E74}"/>
-              </a:ext>
-            </a:extLst>
-          </p:cNvPr>
+            <a:endParaRPr lang="en-US" dirty="0"/>
+          </a:p>
+        </p:txBody>
+      </p:sp>
+      <p:sp>
+        <p:nvSpPr>
+          <p:cNvPr id="3" name="Content Placeholder 2"/>
           <p:cNvSpPr>
             <a:spLocks noGrp="1"/>
           </p:cNvSpPr>
@@ -839,19 +779,13 @@
               <a:rPr lang="en-GB"/>
               <a:t>Fifth level</a:t>
             </a:r>
-            <a:endParaRPr lang="en-NL"/>
-          </a:p>
-        </p:txBody>
-      </p:sp>
-      <p:sp>
-        <p:nvSpPr>
-          <p:cNvPr id="4" name="Date Placeholder 3">
-            <a:extLst>
-              <a:ext uri="{FF2B5EF4-FFF2-40B4-BE49-F238E27FC236}">
-                <a16:creationId xmlns:a16="http://schemas.microsoft.com/office/drawing/2014/main" id="{3FCBAE83-DF94-A1F9-ED9F-2AE23BA82E6B}"/>
-              </a:ext>
-            </a:extLst>
-          </p:cNvPr>
+            <a:endParaRPr lang="en-US" dirty="0"/>
+          </a:p>
+        </p:txBody>
+      </p:sp>
+      <p:sp>
+        <p:nvSpPr>
+          <p:cNvPr id="4" name="Date Placeholder 3"/>
           <p:cNvSpPr>
             <a:spLocks noGrp="1"/>
           </p:cNvSpPr>
@@ -866,7 +800,7 @@
           <a:p>
             <a:fld id="{02A1A179-2826-B94E-B378-7E45598DB11F}" type="datetimeFigureOut">
               <a:rPr lang="en-NL" smtClean="0"/>
-              <a:t>27/07/2026</a:t>
+              <a:t>28/07/2026</a:t>
             </a:fld>
             <a:endParaRPr lang="en-NL"/>
           </a:p>
@@ -874,13 +808,7 @@
       </p:sp>
       <p:sp>
         <p:nvSpPr>
-          <p:cNvPr id="5" name="Footer Placeholder 4">
-            <a:extLst>
-              <a:ext uri="{FF2B5EF4-FFF2-40B4-BE49-F238E27FC236}">
-                <a16:creationId xmlns:a16="http://schemas.microsoft.com/office/drawing/2014/main" id="{B09D6DE5-692D-24CA-4CEE-24C12C943778}"/>
-              </a:ext>
-            </a:extLst>
-          </p:cNvPr>
+          <p:cNvPr id="5" name="Footer Placeholder 4"/>
           <p:cNvSpPr>
             <a:spLocks noGrp="1"/>
           </p:cNvSpPr>
@@ -899,13 +827,7 @@
       </p:sp>
       <p:sp>
         <p:nvSpPr>
-          <p:cNvPr id="6" name="Slide Number Placeholder 5">
-            <a:extLst>
-              <a:ext uri="{FF2B5EF4-FFF2-40B4-BE49-F238E27FC236}">
-                <a16:creationId xmlns:a16="http://schemas.microsoft.com/office/drawing/2014/main" id="{D93F95DD-F2AA-8466-D016-5FDFC1AF2E6C}"/>
-              </a:ext>
-            </a:extLst>
-          </p:cNvPr>
+          <p:cNvPr id="6" name="Slide Number Placeholder 5"/>
           <p:cNvSpPr>
             <a:spLocks noGrp="1"/>
           </p:cNvSpPr>
@@ -929,7 +851,7 @@
     </p:spTree>
     <p:extLst>
       <p:ext uri="{BB962C8B-B14F-4D97-AF65-F5344CB8AC3E}">
-        <p14:creationId xmlns:p14="http://schemas.microsoft.com/office/powerpoint/2010/main" val="4247539262"/>
+        <p14:creationId xmlns:p14="http://schemas.microsoft.com/office/powerpoint/2010/main" val="2309999010"/>
       </p:ext>
     </p:extLst>
   </p:cSld>
@@ -958,13 +880,7 @@
       </p:grpSpPr>
       <p:sp>
         <p:nvSpPr>
-          <p:cNvPr id="2" name="Title 1">
-            <a:extLst>
-              <a:ext uri="{FF2B5EF4-FFF2-40B4-BE49-F238E27FC236}">
-                <a16:creationId xmlns:a16="http://schemas.microsoft.com/office/drawing/2014/main" id="{9843D1F3-A6F5-C2C5-C8AD-B3E6DEACD19D}"/>
-              </a:ext>
-            </a:extLst>
-          </p:cNvPr>
+          <p:cNvPr id="2" name="Title 1"/>
           <p:cNvSpPr>
             <a:spLocks noGrp="1"/>
           </p:cNvSpPr>
@@ -974,15 +890,15 @@
         </p:nvSpPr>
         <p:spPr>
           <a:xfrm>
-            <a:off x="831850" y="1709738"/>
-            <a:ext cx="10515600" cy="2852737"/>
+            <a:off x="368484" y="1256579"/>
+            <a:ext cx="4658082" cy="2096630"/>
           </a:xfrm>
         </p:spPr>
         <p:txBody>
           <a:bodyPr anchor="b"/>
           <a:lstStyle>
             <a:lvl1pPr>
-              <a:defRPr sz="6000"/>
+              <a:defRPr sz="3544"/>
             </a:lvl1pPr>
           </a:lstStyle>
           <a:p>
@@ -990,19 +906,13 @@
               <a:rPr lang="en-GB"/>
               <a:t>Click to edit Master title style</a:t>
             </a:r>
-            <a:endParaRPr lang="en-NL"/>
-          </a:p>
-        </p:txBody>
-      </p:sp>
-      <p:sp>
-        <p:nvSpPr>
-          <p:cNvPr id="3" name="Text Placeholder 2">
-            <a:extLst>
-              <a:ext uri="{FF2B5EF4-FFF2-40B4-BE49-F238E27FC236}">
-                <a16:creationId xmlns:a16="http://schemas.microsoft.com/office/drawing/2014/main" id="{99016D08-9BBF-2F71-9F84-1DADE7934C0F}"/>
-              </a:ext>
-            </a:extLst>
-          </p:cNvPr>
+            <a:endParaRPr lang="en-US" dirty="0"/>
+          </a:p>
+        </p:txBody>
+      </p:sp>
+      <p:sp>
+        <p:nvSpPr>
+          <p:cNvPr id="3" name="Text Placeholder 2"/>
           <p:cNvSpPr>
             <a:spLocks noGrp="1"/>
           </p:cNvSpPr>
@@ -1012,8 +922,8 @@
         </p:nvSpPr>
         <p:spPr>
           <a:xfrm>
-            <a:off x="831850" y="4589463"/>
-            <a:ext cx="10515600" cy="1500187"/>
+            <a:off x="368484" y="3373044"/>
+            <a:ext cx="4658082" cy="1102568"/>
           </a:xfrm>
         </p:spPr>
         <p:txBody>
@@ -1021,7 +931,7 @@
           <a:lstStyle>
             <a:lvl1pPr marL="0" indent="0">
               <a:buNone/>
-              <a:defRPr sz="2400">
+              <a:defRPr sz="1417">
                 <a:solidFill>
                   <a:schemeClr val="tx1">
                     <a:tint val="82000"/>
@@ -1029,9 +939,9 @@
                 </a:solidFill>
               </a:defRPr>
             </a:lvl1pPr>
-            <a:lvl2pPr marL="457200" indent="0">
-              <a:buNone/>
-              <a:defRPr sz="2000">
+            <a:lvl2pPr marL="270022" indent="0">
+              <a:buNone/>
+              <a:defRPr sz="1181">
                 <a:solidFill>
                   <a:schemeClr val="tx1">
                     <a:tint val="82000"/>
@@ -1039,9 +949,9 @@
                 </a:solidFill>
               </a:defRPr>
             </a:lvl2pPr>
-            <a:lvl3pPr marL="914400" indent="0">
-              <a:buNone/>
-              <a:defRPr sz="1800">
+            <a:lvl3pPr marL="540045" indent="0">
+              <a:buNone/>
+              <a:defRPr sz="1063">
                 <a:solidFill>
                   <a:schemeClr val="tx1">
                     <a:tint val="82000"/>
@@ -1049,9 +959,9 @@
                 </a:solidFill>
               </a:defRPr>
             </a:lvl3pPr>
-            <a:lvl4pPr marL="1371600" indent="0">
-              <a:buNone/>
-              <a:defRPr sz="1600">
+            <a:lvl4pPr marL="810067" indent="0">
+              <a:buNone/>
+              <a:defRPr sz="945">
                 <a:solidFill>
                   <a:schemeClr val="tx1">
                     <a:tint val="82000"/>
@@ -1059,9 +969,9 @@
                 </a:solidFill>
               </a:defRPr>
             </a:lvl4pPr>
-            <a:lvl5pPr marL="1828800" indent="0">
-              <a:buNone/>
-              <a:defRPr sz="1600">
+            <a:lvl5pPr marL="1080089" indent="0">
+              <a:buNone/>
+              <a:defRPr sz="945">
                 <a:solidFill>
                   <a:schemeClr val="tx1">
                     <a:tint val="82000"/>
@@ -1069,9 +979,9 @@
                 </a:solidFill>
               </a:defRPr>
             </a:lvl5pPr>
-            <a:lvl6pPr marL="2286000" indent="0">
-              <a:buNone/>
-              <a:defRPr sz="1600">
+            <a:lvl6pPr marL="1350112" indent="0">
+              <a:buNone/>
+              <a:defRPr sz="945">
                 <a:solidFill>
                   <a:schemeClr val="tx1">
                     <a:tint val="82000"/>
@@ -1079,9 +989,9 @@
                 </a:solidFill>
               </a:defRPr>
             </a:lvl6pPr>
-            <a:lvl7pPr marL="2743200" indent="0">
-              <a:buNone/>
-              <a:defRPr sz="1600">
+            <a:lvl7pPr marL="1620134" indent="0">
+              <a:buNone/>
+              <a:defRPr sz="945">
                 <a:solidFill>
                   <a:schemeClr val="tx1">
                     <a:tint val="82000"/>
@@ -1089,9 +999,9 @@
                 </a:solidFill>
               </a:defRPr>
             </a:lvl7pPr>
-            <a:lvl8pPr marL="3200400" indent="0">
-              <a:buNone/>
-              <a:defRPr sz="1600">
+            <a:lvl8pPr marL="1890156" indent="0">
+              <a:buNone/>
+              <a:defRPr sz="945">
                 <a:solidFill>
                   <a:schemeClr val="tx1">
                     <a:tint val="82000"/>
@@ -1099,9 +1009,9 @@
                 </a:solidFill>
               </a:defRPr>
             </a:lvl8pPr>
-            <a:lvl9pPr marL="3657600" indent="0">
-              <a:buNone/>
-              <a:defRPr sz="1600">
+            <a:lvl9pPr marL="2160179" indent="0">
+              <a:buNone/>
+              <a:defRPr sz="945">
                 <a:solidFill>
                   <a:schemeClr val="tx1">
                     <a:tint val="82000"/>
@@ -1121,13 +1031,7 @@
       </p:sp>
       <p:sp>
         <p:nvSpPr>
-          <p:cNvPr id="4" name="Date Placeholder 3">
-            <a:extLst>
-              <a:ext uri="{FF2B5EF4-FFF2-40B4-BE49-F238E27FC236}">
-                <a16:creationId xmlns:a16="http://schemas.microsoft.com/office/drawing/2014/main" id="{98127F98-3410-C3EA-3376-1C7D4E0423DD}"/>
-              </a:ext>
-            </a:extLst>
-          </p:cNvPr>
+          <p:cNvPr id="4" name="Date Placeholder 3"/>
           <p:cNvSpPr>
             <a:spLocks noGrp="1"/>
           </p:cNvSpPr>
@@ -1142,7 +1046,7 @@
           <a:p>
             <a:fld id="{02A1A179-2826-B94E-B378-7E45598DB11F}" type="datetimeFigureOut">
               <a:rPr lang="en-NL" smtClean="0"/>
-              <a:t>27/07/2026</a:t>
+              <a:t>28/07/2026</a:t>
             </a:fld>
             <a:endParaRPr lang="en-NL"/>
           </a:p>
@@ -1150,13 +1054,7 @@
       </p:sp>
       <p:sp>
         <p:nvSpPr>
-          <p:cNvPr id="5" name="Footer Placeholder 4">
-            <a:extLst>
-              <a:ext uri="{FF2B5EF4-FFF2-40B4-BE49-F238E27FC236}">
-                <a16:creationId xmlns:a16="http://schemas.microsoft.com/office/drawing/2014/main" id="{822ABBAC-0E8E-74F8-C5AF-553E85B27D33}"/>
-              </a:ext>
-            </a:extLst>
-          </p:cNvPr>
+          <p:cNvPr id="5" name="Footer Placeholder 4"/>
           <p:cNvSpPr>
             <a:spLocks noGrp="1"/>
           </p:cNvSpPr>
@@ -1175,13 +1073,7 @@
       </p:sp>
       <p:sp>
         <p:nvSpPr>
-          <p:cNvPr id="6" name="Slide Number Placeholder 5">
-            <a:extLst>
-              <a:ext uri="{FF2B5EF4-FFF2-40B4-BE49-F238E27FC236}">
-                <a16:creationId xmlns:a16="http://schemas.microsoft.com/office/drawing/2014/main" id="{5ECAE1B5-8494-35D3-1479-CDF5155C1AE2}"/>
-              </a:ext>
-            </a:extLst>
-          </p:cNvPr>
+          <p:cNvPr id="6" name="Slide Number Placeholder 5"/>
           <p:cNvSpPr>
             <a:spLocks noGrp="1"/>
           </p:cNvSpPr>
@@ -1205,7 +1097,7 @@
     </p:spTree>
     <p:extLst>
       <p:ext uri="{BB962C8B-B14F-4D97-AF65-F5344CB8AC3E}">
-        <p14:creationId xmlns:p14="http://schemas.microsoft.com/office/powerpoint/2010/main" val="1971971095"/>
+        <p14:creationId xmlns:p14="http://schemas.microsoft.com/office/powerpoint/2010/main" val="77592168"/>
       </p:ext>
     </p:extLst>
   </p:cSld>
@@ -1234,13 +1126,7 @@
       </p:grpSpPr>
       <p:sp>
         <p:nvSpPr>
-          <p:cNvPr id="2" name="Title 1">
-            <a:extLst>
-              <a:ext uri="{FF2B5EF4-FFF2-40B4-BE49-F238E27FC236}">
-                <a16:creationId xmlns:a16="http://schemas.microsoft.com/office/drawing/2014/main" id="{2CFC2EBF-EBAF-9FD2-AEEA-C8B7079CD26D}"/>
-              </a:ext>
-            </a:extLst>
-          </p:cNvPr>
+          <p:cNvPr id="2" name="Title 1"/>
           <p:cNvSpPr>
             <a:spLocks noGrp="1"/>
           </p:cNvSpPr>
@@ -1257,19 +1143,13 @@
               <a:rPr lang="en-GB"/>
               <a:t>Click to edit Master title style</a:t>
             </a:r>
-            <a:endParaRPr lang="en-NL"/>
-          </a:p>
-        </p:txBody>
-      </p:sp>
-      <p:sp>
-        <p:nvSpPr>
-          <p:cNvPr id="3" name="Content Placeholder 2">
-            <a:extLst>
-              <a:ext uri="{FF2B5EF4-FFF2-40B4-BE49-F238E27FC236}">
-                <a16:creationId xmlns:a16="http://schemas.microsoft.com/office/drawing/2014/main" id="{3D531D2E-9B28-FCA5-EC82-B04FED330566}"/>
-              </a:ext>
-            </a:extLst>
-          </p:cNvPr>
+            <a:endParaRPr lang="en-US" dirty="0"/>
+          </a:p>
+        </p:txBody>
+      </p:sp>
+      <p:sp>
+        <p:nvSpPr>
+          <p:cNvPr id="3" name="Content Placeholder 2"/>
           <p:cNvSpPr>
             <a:spLocks noGrp="1"/>
           </p:cNvSpPr>
@@ -1279,8 +1159,8 @@
         </p:nvSpPr>
         <p:spPr>
           <a:xfrm>
-            <a:off x="838200" y="1825625"/>
-            <a:ext cx="5181600" cy="4351338"/>
+            <a:off x="371296" y="1341750"/>
+            <a:ext cx="2295287" cy="3198032"/>
           </a:xfrm>
         </p:spPr>
         <p:txBody>
@@ -1320,19 +1200,13 @@
               <a:rPr lang="en-GB"/>
               <a:t>Fifth level</a:t>
             </a:r>
-            <a:endParaRPr lang="en-NL"/>
-          </a:p>
-        </p:txBody>
-      </p:sp>
-      <p:sp>
-        <p:nvSpPr>
-          <p:cNvPr id="4" name="Content Placeholder 3">
-            <a:extLst>
-              <a:ext uri="{FF2B5EF4-FFF2-40B4-BE49-F238E27FC236}">
-                <a16:creationId xmlns:a16="http://schemas.microsoft.com/office/drawing/2014/main" id="{C4F15FD2-3245-E239-F5ED-6CE65CDC0417}"/>
-              </a:ext>
-            </a:extLst>
-          </p:cNvPr>
+            <a:endParaRPr lang="en-US" dirty="0"/>
+          </a:p>
+        </p:txBody>
+      </p:sp>
+      <p:sp>
+        <p:nvSpPr>
+          <p:cNvPr id="4" name="Content Placeholder 3"/>
           <p:cNvSpPr>
             <a:spLocks noGrp="1"/>
           </p:cNvSpPr>
@@ -1342,8 +1216,8 @@
         </p:nvSpPr>
         <p:spPr>
           <a:xfrm>
-            <a:off x="6172200" y="1825625"/>
-            <a:ext cx="5181600" cy="4351338"/>
+            <a:off x="2734092" y="1341750"/>
+            <a:ext cx="2295287" cy="3198032"/>
           </a:xfrm>
         </p:spPr>
         <p:txBody>
@@ -1383,19 +1257,13 @@
               <a:rPr lang="en-GB"/>
               <a:t>Fifth level</a:t>
             </a:r>
-            <a:endParaRPr lang="en-NL"/>
-          </a:p>
-        </p:txBody>
-      </p:sp>
-      <p:sp>
-        <p:nvSpPr>
-          <p:cNvPr id="5" name="Date Placeholder 4">
-            <a:extLst>
-              <a:ext uri="{FF2B5EF4-FFF2-40B4-BE49-F238E27FC236}">
-                <a16:creationId xmlns:a16="http://schemas.microsoft.com/office/drawing/2014/main" id="{7E1554EE-DD72-24FD-2CD2-A602515F63D3}"/>
-              </a:ext>
-            </a:extLst>
-          </p:cNvPr>
+            <a:endParaRPr lang="en-US" dirty="0"/>
+          </a:p>
+        </p:txBody>
+      </p:sp>
+      <p:sp>
+        <p:nvSpPr>
+          <p:cNvPr id="5" name="Date Placeholder 4"/>
           <p:cNvSpPr>
             <a:spLocks noGrp="1"/>
           </p:cNvSpPr>
@@ -1410,7 +1278,7 @@
           <a:p>
             <a:fld id="{02A1A179-2826-B94E-B378-7E45598DB11F}" type="datetimeFigureOut">
               <a:rPr lang="en-NL" smtClean="0"/>
-              <a:t>27/07/2026</a:t>
+              <a:t>28/07/2026</a:t>
             </a:fld>
             <a:endParaRPr lang="en-NL"/>
           </a:p>
@@ -1418,13 +1286,7 @@
       </p:sp>
       <p:sp>
         <p:nvSpPr>
-          <p:cNvPr id="6" name="Footer Placeholder 5">
-            <a:extLst>
-              <a:ext uri="{FF2B5EF4-FFF2-40B4-BE49-F238E27FC236}">
-                <a16:creationId xmlns:a16="http://schemas.microsoft.com/office/drawing/2014/main" id="{9837C7FE-B40D-C5C4-8E81-FD203EFC21BD}"/>
-              </a:ext>
-            </a:extLst>
-          </p:cNvPr>
+          <p:cNvPr id="6" name="Footer Placeholder 5"/>
           <p:cNvSpPr>
             <a:spLocks noGrp="1"/>
           </p:cNvSpPr>
@@ -1443,13 +1305,7 @@
       </p:sp>
       <p:sp>
         <p:nvSpPr>
-          <p:cNvPr id="7" name="Slide Number Placeholder 6">
-            <a:extLst>
-              <a:ext uri="{FF2B5EF4-FFF2-40B4-BE49-F238E27FC236}">
-                <a16:creationId xmlns:a16="http://schemas.microsoft.com/office/drawing/2014/main" id="{7BF02708-07B8-58CE-D342-BD3C10F4EFA6}"/>
-              </a:ext>
-            </a:extLst>
-          </p:cNvPr>
+          <p:cNvPr id="7" name="Slide Number Placeholder 6"/>
           <p:cNvSpPr>
             <a:spLocks noGrp="1"/>
           </p:cNvSpPr>
@@ -1473,7 +1329,7 @@
     </p:spTree>
     <p:extLst>
       <p:ext uri="{BB962C8B-B14F-4D97-AF65-F5344CB8AC3E}">
-        <p14:creationId xmlns:p14="http://schemas.microsoft.com/office/powerpoint/2010/main" val="2351060071"/>
+        <p14:creationId xmlns:p14="http://schemas.microsoft.com/office/powerpoint/2010/main" val="3094473734"/>
       </p:ext>
     </p:extLst>
   </p:cSld>
@@ -1502,13 +1358,7 @@
       </p:grpSpPr>
       <p:sp>
         <p:nvSpPr>
-          <p:cNvPr id="2" name="Title 1">
-            <a:extLst>
-              <a:ext uri="{FF2B5EF4-FFF2-40B4-BE49-F238E27FC236}">
-                <a16:creationId xmlns:a16="http://schemas.microsoft.com/office/drawing/2014/main" id="{C63A0FBF-EB08-6205-B94B-73D3C20C531F}"/>
-              </a:ext>
-            </a:extLst>
-          </p:cNvPr>
+          <p:cNvPr id="2" name="Title 1"/>
           <p:cNvSpPr>
             <a:spLocks noGrp="1"/>
           </p:cNvSpPr>
@@ -1518,8 +1368,8 @@
         </p:nvSpPr>
         <p:spPr>
           <a:xfrm>
-            <a:off x="839788" y="365125"/>
-            <a:ext cx="10515600" cy="1325563"/>
+            <a:off x="372000" y="268351"/>
+            <a:ext cx="4658082" cy="974228"/>
           </a:xfrm>
         </p:spPr>
         <p:txBody>
@@ -1530,19 +1380,13 @@
               <a:rPr lang="en-GB"/>
               <a:t>Click to edit Master title style</a:t>
             </a:r>
-            <a:endParaRPr lang="en-NL"/>
-          </a:p>
-        </p:txBody>
-      </p:sp>
-      <p:sp>
-        <p:nvSpPr>
-          <p:cNvPr id="3" name="Text Placeholder 2">
-            <a:extLst>
-              <a:ext uri="{FF2B5EF4-FFF2-40B4-BE49-F238E27FC236}">
-                <a16:creationId xmlns:a16="http://schemas.microsoft.com/office/drawing/2014/main" id="{2B9CC43B-68A3-8EC9-5171-96C76D5BCA3B}"/>
-              </a:ext>
-            </a:extLst>
-          </p:cNvPr>
+            <a:endParaRPr lang="en-US" dirty="0"/>
+          </a:p>
+        </p:txBody>
+      </p:sp>
+      <p:sp>
+        <p:nvSpPr>
+          <p:cNvPr id="3" name="Text Placeholder 2"/>
           <p:cNvSpPr>
             <a:spLocks noGrp="1"/>
           </p:cNvSpPr>
@@ -1552,8 +1396,8 @@
         </p:nvSpPr>
         <p:spPr>
           <a:xfrm>
-            <a:off x="839788" y="1681163"/>
-            <a:ext cx="5157787" cy="823912"/>
+            <a:off x="372001" y="1235577"/>
+            <a:ext cx="2284738" cy="605537"/>
           </a:xfrm>
         </p:spPr>
         <p:txBody>
@@ -1561,39 +1405,39 @@
           <a:lstStyle>
             <a:lvl1pPr marL="0" indent="0">
               <a:buNone/>
-              <a:defRPr sz="2400" b="1"/>
+              <a:defRPr sz="1417" b="1"/>
             </a:lvl1pPr>
-            <a:lvl2pPr marL="457200" indent="0">
-              <a:buNone/>
-              <a:defRPr sz="2000" b="1"/>
+            <a:lvl2pPr marL="270022" indent="0">
+              <a:buNone/>
+              <a:defRPr sz="1181" b="1"/>
             </a:lvl2pPr>
-            <a:lvl3pPr marL="914400" indent="0">
-              <a:buNone/>
-              <a:defRPr sz="1800" b="1"/>
+            <a:lvl3pPr marL="540045" indent="0">
+              <a:buNone/>
+              <a:defRPr sz="1063" b="1"/>
             </a:lvl3pPr>
-            <a:lvl4pPr marL="1371600" indent="0">
-              <a:buNone/>
-              <a:defRPr sz="1600" b="1"/>
+            <a:lvl4pPr marL="810067" indent="0">
+              <a:buNone/>
+              <a:defRPr sz="945" b="1"/>
             </a:lvl4pPr>
-            <a:lvl5pPr marL="1828800" indent="0">
-              <a:buNone/>
-              <a:defRPr sz="1600" b="1"/>
+            <a:lvl5pPr marL="1080089" indent="0">
+              <a:buNone/>
+              <a:defRPr sz="945" b="1"/>
             </a:lvl5pPr>
-            <a:lvl6pPr marL="2286000" indent="0">
-              <a:buNone/>
-              <a:defRPr sz="1600" b="1"/>
+            <a:lvl6pPr marL="1350112" indent="0">
+              <a:buNone/>
+              <a:defRPr sz="945" b="1"/>
             </a:lvl6pPr>
-            <a:lvl7pPr marL="2743200" indent="0">
-              <a:buNone/>
-              <a:defRPr sz="1600" b="1"/>
+            <a:lvl7pPr marL="1620134" indent="0">
+              <a:buNone/>
+              <a:defRPr sz="945" b="1"/>
             </a:lvl7pPr>
-            <a:lvl8pPr marL="3200400" indent="0">
-              <a:buNone/>
-              <a:defRPr sz="1600" b="1"/>
+            <a:lvl8pPr marL="1890156" indent="0">
+              <a:buNone/>
+              <a:defRPr sz="945" b="1"/>
             </a:lvl8pPr>
-            <a:lvl9pPr marL="3657600" indent="0">
-              <a:buNone/>
-              <a:defRPr sz="1600" b="1"/>
+            <a:lvl9pPr marL="2160179" indent="0">
+              <a:buNone/>
+              <a:defRPr sz="945" b="1"/>
             </a:lvl9pPr>
           </a:lstStyle>
           <a:p>
@@ -1607,13 +1451,7 @@
       </p:sp>
       <p:sp>
         <p:nvSpPr>
-          <p:cNvPr id="4" name="Content Placeholder 3">
-            <a:extLst>
-              <a:ext uri="{FF2B5EF4-FFF2-40B4-BE49-F238E27FC236}">
-                <a16:creationId xmlns:a16="http://schemas.microsoft.com/office/drawing/2014/main" id="{468924EB-20C6-AC1B-292F-94F2D9CCFC91}"/>
-              </a:ext>
-            </a:extLst>
-          </p:cNvPr>
+          <p:cNvPr id="4" name="Content Placeholder 3"/>
           <p:cNvSpPr>
             <a:spLocks noGrp="1"/>
           </p:cNvSpPr>
@@ -1623,8 +1461,8 @@
         </p:nvSpPr>
         <p:spPr>
           <a:xfrm>
-            <a:off x="839788" y="2505075"/>
-            <a:ext cx="5157787" cy="3684588"/>
+            <a:off x="372001" y="1841114"/>
+            <a:ext cx="2284738" cy="2708002"/>
           </a:xfrm>
         </p:spPr>
         <p:txBody>
@@ -1664,19 +1502,13 @@
               <a:rPr lang="en-GB"/>
               <a:t>Fifth level</a:t>
             </a:r>
-            <a:endParaRPr lang="en-NL"/>
-          </a:p>
-        </p:txBody>
-      </p:sp>
-      <p:sp>
-        <p:nvSpPr>
-          <p:cNvPr id="5" name="Text Placeholder 4">
-            <a:extLst>
-              <a:ext uri="{FF2B5EF4-FFF2-40B4-BE49-F238E27FC236}">
-                <a16:creationId xmlns:a16="http://schemas.microsoft.com/office/drawing/2014/main" id="{BCC7313B-B916-3989-E3F5-44FB053B0053}"/>
-              </a:ext>
-            </a:extLst>
-          </p:cNvPr>
+            <a:endParaRPr lang="en-US" dirty="0"/>
+          </a:p>
+        </p:txBody>
+      </p:sp>
+      <p:sp>
+        <p:nvSpPr>
+          <p:cNvPr id="5" name="Text Placeholder 4"/>
           <p:cNvSpPr>
             <a:spLocks noGrp="1"/>
           </p:cNvSpPr>
@@ -1686,8 +1518,8 @@
         </p:nvSpPr>
         <p:spPr>
           <a:xfrm>
-            <a:off x="6172200" y="1681163"/>
-            <a:ext cx="5183188" cy="823912"/>
+            <a:off x="2734092" y="1235577"/>
+            <a:ext cx="2295990" cy="605537"/>
           </a:xfrm>
         </p:spPr>
         <p:txBody>
@@ -1695,39 +1527,39 @@
           <a:lstStyle>
             <a:lvl1pPr marL="0" indent="0">
               <a:buNone/>
-              <a:defRPr sz="2400" b="1"/>
+              <a:defRPr sz="1417" b="1"/>
             </a:lvl1pPr>
-            <a:lvl2pPr marL="457200" indent="0">
-              <a:buNone/>
-              <a:defRPr sz="2000" b="1"/>
+            <a:lvl2pPr marL="270022" indent="0">
+              <a:buNone/>
+              <a:defRPr sz="1181" b="1"/>
             </a:lvl2pPr>
-            <a:lvl3pPr marL="914400" indent="0">
-              <a:buNone/>
-              <a:defRPr sz="1800" b="1"/>
+            <a:lvl3pPr marL="540045" indent="0">
+              <a:buNone/>
+              <a:defRPr sz="1063" b="1"/>
             </a:lvl3pPr>
-            <a:lvl4pPr marL="1371600" indent="0">
-              <a:buNone/>
-              <a:defRPr sz="1600" b="1"/>
+            <a:lvl4pPr marL="810067" indent="0">
+              <a:buNone/>
+              <a:defRPr sz="945" b="1"/>
             </a:lvl4pPr>
-            <a:lvl5pPr marL="1828800" indent="0">
-              <a:buNone/>
-              <a:defRPr sz="1600" b="1"/>
+            <a:lvl5pPr marL="1080089" indent="0">
+              <a:buNone/>
+              <a:defRPr sz="945" b="1"/>
             </a:lvl5pPr>
-            <a:lvl6pPr marL="2286000" indent="0">
-              <a:buNone/>
-              <a:defRPr sz="1600" b="1"/>
+            <a:lvl6pPr marL="1350112" indent="0">
+              <a:buNone/>
+              <a:defRPr sz="945" b="1"/>
             </a:lvl6pPr>
-            <a:lvl7pPr marL="2743200" indent="0">
-              <a:buNone/>
-              <a:defRPr sz="1600" b="1"/>
+            <a:lvl7pPr marL="1620134" indent="0">
+              <a:buNone/>
+              <a:defRPr sz="945" b="1"/>
             </a:lvl7pPr>
-            <a:lvl8pPr marL="3200400" indent="0">
-              <a:buNone/>
-              <a:defRPr sz="1600" b="1"/>
+            <a:lvl8pPr marL="1890156" indent="0">
+              <a:buNone/>
+              <a:defRPr sz="945" b="1"/>
             </a:lvl8pPr>
-            <a:lvl9pPr marL="3657600" indent="0">
-              <a:buNone/>
-              <a:defRPr sz="1600" b="1"/>
+            <a:lvl9pPr marL="2160179" indent="0">
+              <a:buNone/>
+              <a:defRPr sz="945" b="1"/>
             </a:lvl9pPr>
           </a:lstStyle>
           <a:p>
@@ -1741,13 +1573,7 @@
       </p:sp>
       <p:sp>
         <p:nvSpPr>
-          <p:cNvPr id="6" name="Content Placeholder 5">
-            <a:extLst>
-              <a:ext uri="{FF2B5EF4-FFF2-40B4-BE49-F238E27FC236}">
-                <a16:creationId xmlns:a16="http://schemas.microsoft.com/office/drawing/2014/main" id="{630A11AC-A452-7C0D-ED44-0ECBF3FD89CD}"/>
-              </a:ext>
-            </a:extLst>
-          </p:cNvPr>
+          <p:cNvPr id="6" name="Content Placeholder 5"/>
           <p:cNvSpPr>
             <a:spLocks noGrp="1"/>
           </p:cNvSpPr>
@@ -1757,8 +1583,8 @@
         </p:nvSpPr>
         <p:spPr>
           <a:xfrm>
-            <a:off x="6172200" y="2505075"/>
-            <a:ext cx="5183188" cy="3684588"/>
+            <a:off x="2734092" y="1841114"/>
+            <a:ext cx="2295990" cy="2708002"/>
           </a:xfrm>
         </p:spPr>
         <p:txBody>
@@ -1798,19 +1624,13 @@
               <a:rPr lang="en-GB"/>
               <a:t>Fifth level</a:t>
             </a:r>
-            <a:endParaRPr lang="en-NL"/>
-          </a:p>
-        </p:txBody>
-      </p:sp>
-      <p:sp>
-        <p:nvSpPr>
-          <p:cNvPr id="7" name="Date Placeholder 6">
-            <a:extLst>
-              <a:ext uri="{FF2B5EF4-FFF2-40B4-BE49-F238E27FC236}">
-                <a16:creationId xmlns:a16="http://schemas.microsoft.com/office/drawing/2014/main" id="{D143C78E-1B68-EC5A-3AED-7D1CC5FEF149}"/>
-              </a:ext>
-            </a:extLst>
-          </p:cNvPr>
+            <a:endParaRPr lang="en-US" dirty="0"/>
+          </a:p>
+        </p:txBody>
+      </p:sp>
+      <p:sp>
+        <p:nvSpPr>
+          <p:cNvPr id="7" name="Date Placeholder 6"/>
           <p:cNvSpPr>
             <a:spLocks noGrp="1"/>
           </p:cNvSpPr>
@@ -1825,7 +1645,7 @@
           <a:p>
             <a:fld id="{02A1A179-2826-B94E-B378-7E45598DB11F}" type="datetimeFigureOut">
               <a:rPr lang="en-NL" smtClean="0"/>
-              <a:t>27/07/2026</a:t>
+              <a:t>28/07/2026</a:t>
             </a:fld>
             <a:endParaRPr lang="en-NL"/>
           </a:p>
@@ -1833,13 +1653,7 @@
       </p:sp>
       <p:sp>
         <p:nvSpPr>
-          <p:cNvPr id="8" name="Footer Placeholder 7">
-            <a:extLst>
-              <a:ext uri="{FF2B5EF4-FFF2-40B4-BE49-F238E27FC236}">
-                <a16:creationId xmlns:a16="http://schemas.microsoft.com/office/drawing/2014/main" id="{56AB94E1-95A5-32C1-27F1-2A373A267D9B}"/>
-              </a:ext>
-            </a:extLst>
-          </p:cNvPr>
+          <p:cNvPr id="8" name="Footer Placeholder 7"/>
           <p:cNvSpPr>
             <a:spLocks noGrp="1"/>
           </p:cNvSpPr>
@@ -1858,13 +1672,7 @@
       </p:sp>
       <p:sp>
         <p:nvSpPr>
-          <p:cNvPr id="9" name="Slide Number Placeholder 8">
-            <a:extLst>
-              <a:ext uri="{FF2B5EF4-FFF2-40B4-BE49-F238E27FC236}">
-                <a16:creationId xmlns:a16="http://schemas.microsoft.com/office/drawing/2014/main" id="{A870F46C-CBBD-9E4F-3685-9AFA1452F7ED}"/>
-              </a:ext>
-            </a:extLst>
-          </p:cNvPr>
+          <p:cNvPr id="9" name="Slide Number Placeholder 8"/>
           <p:cNvSpPr>
             <a:spLocks noGrp="1"/>
           </p:cNvSpPr>
@@ -1888,7 +1696,7 @@
     </p:spTree>
     <p:extLst>
       <p:ext uri="{BB962C8B-B14F-4D97-AF65-F5344CB8AC3E}">
-        <p14:creationId xmlns:p14="http://schemas.microsoft.com/office/powerpoint/2010/main" val="1122173029"/>
+        <p14:creationId xmlns:p14="http://schemas.microsoft.com/office/powerpoint/2010/main" val="1260794164"/>
       </p:ext>
     </p:extLst>
   </p:cSld>
@@ -1917,13 +1725,7 @@
       </p:grpSpPr>
       <p:sp>
         <p:nvSpPr>
-          <p:cNvPr id="2" name="Title 1">
-            <a:extLst>
-              <a:ext uri="{FF2B5EF4-FFF2-40B4-BE49-F238E27FC236}">
-                <a16:creationId xmlns:a16="http://schemas.microsoft.com/office/drawing/2014/main" id="{37829026-29E7-BBE7-0DB6-8BFFB92F45A9}"/>
-              </a:ext>
-            </a:extLst>
-          </p:cNvPr>
+          <p:cNvPr id="2" name="Title 1"/>
           <p:cNvSpPr>
             <a:spLocks noGrp="1"/>
           </p:cNvSpPr>
@@ -1940,19 +1742,13 @@
               <a:rPr lang="en-GB"/>
               <a:t>Click to edit Master title style</a:t>
             </a:r>
-            <a:endParaRPr lang="en-NL"/>
-          </a:p>
-        </p:txBody>
-      </p:sp>
-      <p:sp>
-        <p:nvSpPr>
-          <p:cNvPr id="3" name="Date Placeholder 2">
-            <a:extLst>
-              <a:ext uri="{FF2B5EF4-FFF2-40B4-BE49-F238E27FC236}">
-                <a16:creationId xmlns:a16="http://schemas.microsoft.com/office/drawing/2014/main" id="{B6068189-F9F0-37DB-BECC-EBC61D0CEA17}"/>
-              </a:ext>
-            </a:extLst>
-          </p:cNvPr>
+            <a:endParaRPr lang="en-US" dirty="0"/>
+          </a:p>
+        </p:txBody>
+      </p:sp>
+      <p:sp>
+        <p:nvSpPr>
+          <p:cNvPr id="3" name="Date Placeholder 2"/>
           <p:cNvSpPr>
             <a:spLocks noGrp="1"/>
           </p:cNvSpPr>
@@ -1967,7 +1763,7 @@
           <a:p>
             <a:fld id="{02A1A179-2826-B94E-B378-7E45598DB11F}" type="datetimeFigureOut">
               <a:rPr lang="en-NL" smtClean="0"/>
-              <a:t>27/07/2026</a:t>
+              <a:t>28/07/2026</a:t>
             </a:fld>
             <a:endParaRPr lang="en-NL"/>
           </a:p>
@@ -1975,13 +1771,7 @@
       </p:sp>
       <p:sp>
         <p:nvSpPr>
-          <p:cNvPr id="4" name="Footer Placeholder 3">
-            <a:extLst>
-              <a:ext uri="{FF2B5EF4-FFF2-40B4-BE49-F238E27FC236}">
-                <a16:creationId xmlns:a16="http://schemas.microsoft.com/office/drawing/2014/main" id="{9BE603C9-0B91-87E0-0F63-D01BEED739CE}"/>
-              </a:ext>
-            </a:extLst>
-          </p:cNvPr>
+          <p:cNvPr id="4" name="Footer Placeholder 3"/>
           <p:cNvSpPr>
             <a:spLocks noGrp="1"/>
           </p:cNvSpPr>
@@ -2000,13 +1790,7 @@
       </p:sp>
       <p:sp>
         <p:nvSpPr>
-          <p:cNvPr id="5" name="Slide Number Placeholder 4">
-            <a:extLst>
-              <a:ext uri="{FF2B5EF4-FFF2-40B4-BE49-F238E27FC236}">
-                <a16:creationId xmlns:a16="http://schemas.microsoft.com/office/drawing/2014/main" id="{3D8F6FC9-6C1A-24A8-C7AB-9B2D34B4951D}"/>
-              </a:ext>
-            </a:extLst>
-          </p:cNvPr>
+          <p:cNvPr id="5" name="Slide Number Placeholder 4"/>
           <p:cNvSpPr>
             <a:spLocks noGrp="1"/>
           </p:cNvSpPr>
@@ -2030,7 +1814,7 @@
     </p:spTree>
     <p:extLst>
       <p:ext uri="{BB962C8B-B14F-4D97-AF65-F5344CB8AC3E}">
-        <p14:creationId xmlns:p14="http://schemas.microsoft.com/office/powerpoint/2010/main" val="1273525630"/>
+        <p14:creationId xmlns:p14="http://schemas.microsoft.com/office/powerpoint/2010/main" val="932285188"/>
       </p:ext>
     </p:extLst>
   </p:cSld>
@@ -2059,13 +1843,7 @@
       </p:grpSpPr>
       <p:sp>
         <p:nvSpPr>
-          <p:cNvPr id="2" name="Date Placeholder 1">
-            <a:extLst>
-              <a:ext uri="{FF2B5EF4-FFF2-40B4-BE49-F238E27FC236}">
-                <a16:creationId xmlns:a16="http://schemas.microsoft.com/office/drawing/2014/main" id="{AF0F20DE-63C9-7E41-011D-847E4DD5BEE2}"/>
-              </a:ext>
-            </a:extLst>
-          </p:cNvPr>
+          <p:cNvPr id="2" name="Date Placeholder 1"/>
           <p:cNvSpPr>
             <a:spLocks noGrp="1"/>
           </p:cNvSpPr>
@@ -2080,7 +1858,7 @@
           <a:p>
             <a:fld id="{02A1A179-2826-B94E-B378-7E45598DB11F}" type="datetimeFigureOut">
               <a:rPr lang="en-NL" smtClean="0"/>
-              <a:t>27/07/2026</a:t>
+              <a:t>28/07/2026</a:t>
             </a:fld>
             <a:endParaRPr lang="en-NL"/>
           </a:p>
@@ -2088,13 +1866,7 @@
       </p:sp>
       <p:sp>
         <p:nvSpPr>
-          <p:cNvPr id="3" name="Footer Placeholder 2">
-            <a:extLst>
-              <a:ext uri="{FF2B5EF4-FFF2-40B4-BE49-F238E27FC236}">
-                <a16:creationId xmlns:a16="http://schemas.microsoft.com/office/drawing/2014/main" id="{9F92BF2E-CC9F-1F72-4091-93B27C3D11C7}"/>
-              </a:ext>
-            </a:extLst>
-          </p:cNvPr>
+          <p:cNvPr id="3" name="Footer Placeholder 2"/>
           <p:cNvSpPr>
             <a:spLocks noGrp="1"/>
           </p:cNvSpPr>
@@ -2113,13 +1885,7 @@
       </p:sp>
       <p:sp>
         <p:nvSpPr>
-          <p:cNvPr id="4" name="Slide Number Placeholder 3">
-            <a:extLst>
-              <a:ext uri="{FF2B5EF4-FFF2-40B4-BE49-F238E27FC236}">
-                <a16:creationId xmlns:a16="http://schemas.microsoft.com/office/drawing/2014/main" id="{E3F94D94-F10A-31AA-4CEF-498C4608529E}"/>
-              </a:ext>
-            </a:extLst>
-          </p:cNvPr>
+          <p:cNvPr id="4" name="Slide Number Placeholder 3"/>
           <p:cNvSpPr>
             <a:spLocks noGrp="1"/>
           </p:cNvSpPr>
@@ -2143,7 +1909,7 @@
     </p:spTree>
     <p:extLst>
       <p:ext uri="{BB962C8B-B14F-4D97-AF65-F5344CB8AC3E}">
-        <p14:creationId xmlns:p14="http://schemas.microsoft.com/office/powerpoint/2010/main" val="1955740026"/>
+        <p14:creationId xmlns:p14="http://schemas.microsoft.com/office/powerpoint/2010/main" val="581832879"/>
       </p:ext>
     </p:extLst>
   </p:cSld>
@@ -2172,13 +1938,7 @@
       </p:grpSpPr>
       <p:sp>
         <p:nvSpPr>
-          <p:cNvPr id="2" name="Title 1">
-            <a:extLst>
-              <a:ext uri="{FF2B5EF4-FFF2-40B4-BE49-F238E27FC236}">
-                <a16:creationId xmlns:a16="http://schemas.microsoft.com/office/drawing/2014/main" id="{322E9775-ED62-7C98-1B01-7B902D75A333}"/>
-              </a:ext>
-            </a:extLst>
-          </p:cNvPr>
+          <p:cNvPr id="2" name="Title 1"/>
           <p:cNvSpPr>
             <a:spLocks noGrp="1"/>
           </p:cNvSpPr>
@@ -2188,15 +1948,15 @@
         </p:nvSpPr>
         <p:spPr>
           <a:xfrm>
-            <a:off x="839788" y="457200"/>
-            <a:ext cx="3932237" cy="1600200"/>
+            <a:off x="372000" y="336021"/>
+            <a:ext cx="1741858" cy="1176073"/>
           </a:xfrm>
         </p:spPr>
         <p:txBody>
           <a:bodyPr anchor="b"/>
           <a:lstStyle>
             <a:lvl1pPr>
-              <a:defRPr sz="3200"/>
+              <a:defRPr sz="1890"/>
             </a:lvl1pPr>
           </a:lstStyle>
           <a:p>
@@ -2204,19 +1964,13 @@
               <a:rPr lang="en-GB"/>
               <a:t>Click to edit Master title style</a:t>
             </a:r>
-            <a:endParaRPr lang="en-NL"/>
-          </a:p>
-        </p:txBody>
-      </p:sp>
-      <p:sp>
-        <p:nvSpPr>
-          <p:cNvPr id="3" name="Content Placeholder 2">
-            <a:extLst>
-              <a:ext uri="{FF2B5EF4-FFF2-40B4-BE49-F238E27FC236}">
-                <a16:creationId xmlns:a16="http://schemas.microsoft.com/office/drawing/2014/main" id="{5816B1E3-C339-C867-DF10-A5C82096AFAE}"/>
-              </a:ext>
-            </a:extLst>
-          </p:cNvPr>
+            <a:endParaRPr lang="en-US" dirty="0"/>
+          </a:p>
+        </p:txBody>
+      </p:sp>
+      <p:sp>
+        <p:nvSpPr>
+          <p:cNvPr id="3" name="Content Placeholder 2"/>
           <p:cNvSpPr>
             <a:spLocks noGrp="1"/>
           </p:cNvSpPr>
@@ -2226,39 +1980,39 @@
         </p:nvSpPr>
         <p:spPr>
           <a:xfrm>
-            <a:off x="5183188" y="987425"/>
-            <a:ext cx="6172200" cy="4873625"/>
+            <a:off x="2295990" y="725713"/>
+            <a:ext cx="2734092" cy="3581889"/>
           </a:xfrm>
         </p:spPr>
         <p:txBody>
           <a:bodyPr/>
           <a:lstStyle>
             <a:lvl1pPr>
-              <a:defRPr sz="3200"/>
+              <a:defRPr sz="1890"/>
             </a:lvl1pPr>
             <a:lvl2pPr>
-              <a:defRPr sz="2800"/>
+              <a:defRPr sz="1654"/>
             </a:lvl2pPr>
             <a:lvl3pPr>
-              <a:defRPr sz="2400"/>
+              <a:defRPr sz="1417"/>
             </a:lvl3pPr>
             <a:lvl4pPr>
-              <a:defRPr sz="2000"/>
+              <a:defRPr sz="1181"/>
             </a:lvl4pPr>
             <a:lvl5pPr>
-              <a:defRPr sz="2000"/>
+              <a:defRPr sz="1181"/>
             </a:lvl5pPr>
             <a:lvl6pPr>
-              <a:defRPr sz="2000"/>
+              <a:defRPr sz="1181"/>
             </a:lvl6pPr>
             <a:lvl7pPr>
-              <a:defRPr sz="2000"/>
+              <a:defRPr sz="1181"/>
             </a:lvl7pPr>
             <a:lvl8pPr>
-              <a:defRPr sz="2000"/>
+              <a:defRPr sz="1181"/>
             </a:lvl8pPr>
             <a:lvl9pPr>
-              <a:defRPr sz="2000"/>
+              <a:defRPr sz="1181"/>
             </a:lvl9pPr>
           </a:lstStyle>
           <a:p>
@@ -2295,19 +2049,13 @@
               <a:rPr lang="en-GB"/>
               <a:t>Fifth level</a:t>
             </a:r>
-            <a:endParaRPr lang="en-NL"/>
-          </a:p>
-        </p:txBody>
-      </p:sp>
-      <p:sp>
-        <p:nvSpPr>
-          <p:cNvPr id="4" name="Text Placeholder 3">
-            <a:extLst>
-              <a:ext uri="{FF2B5EF4-FFF2-40B4-BE49-F238E27FC236}">
-                <a16:creationId xmlns:a16="http://schemas.microsoft.com/office/drawing/2014/main" id="{7350142F-6CE2-7D0A-4C67-9F6D3FE848D9}"/>
-              </a:ext>
-            </a:extLst>
-          </p:cNvPr>
+            <a:endParaRPr lang="en-US" dirty="0"/>
+          </a:p>
+        </p:txBody>
+      </p:sp>
+      <p:sp>
+        <p:nvSpPr>
+          <p:cNvPr id="4" name="Text Placeholder 3"/>
           <p:cNvSpPr>
             <a:spLocks noGrp="1"/>
           </p:cNvSpPr>
@@ -2317,8 +2065,8 @@
         </p:nvSpPr>
         <p:spPr>
           <a:xfrm>
-            <a:off x="839788" y="2057400"/>
-            <a:ext cx="3932237" cy="3811588"/>
+            <a:off x="372000" y="1512094"/>
+            <a:ext cx="1741858" cy="2801341"/>
           </a:xfrm>
         </p:spPr>
         <p:txBody>
@@ -2326,39 +2074,39 @@
           <a:lstStyle>
             <a:lvl1pPr marL="0" indent="0">
               <a:buNone/>
-              <a:defRPr sz="1600"/>
+              <a:defRPr sz="945"/>
             </a:lvl1pPr>
-            <a:lvl2pPr marL="457200" indent="0">
-              <a:buNone/>
-              <a:defRPr sz="1400"/>
+            <a:lvl2pPr marL="270022" indent="0">
+              <a:buNone/>
+              <a:defRPr sz="827"/>
             </a:lvl2pPr>
-            <a:lvl3pPr marL="914400" indent="0">
-              <a:buNone/>
-              <a:defRPr sz="1200"/>
+            <a:lvl3pPr marL="540045" indent="0">
+              <a:buNone/>
+              <a:defRPr sz="709"/>
             </a:lvl3pPr>
-            <a:lvl4pPr marL="1371600" indent="0">
-              <a:buNone/>
-              <a:defRPr sz="1000"/>
+            <a:lvl4pPr marL="810067" indent="0">
+              <a:buNone/>
+              <a:defRPr sz="591"/>
             </a:lvl4pPr>
-            <a:lvl5pPr marL="1828800" indent="0">
-              <a:buNone/>
-              <a:defRPr sz="1000"/>
+            <a:lvl5pPr marL="1080089" indent="0">
+              <a:buNone/>
+              <a:defRPr sz="591"/>
             </a:lvl5pPr>
-            <a:lvl6pPr marL="2286000" indent="0">
-              <a:buNone/>
-              <a:defRPr sz="1000"/>
+            <a:lvl6pPr marL="1350112" indent="0">
+              <a:buNone/>
+              <a:defRPr sz="591"/>
             </a:lvl6pPr>
-            <a:lvl7pPr marL="2743200" indent="0">
-              <a:buNone/>
-              <a:defRPr sz="1000"/>
+            <a:lvl7pPr marL="1620134" indent="0">
+              <a:buNone/>
+              <a:defRPr sz="591"/>
             </a:lvl7pPr>
-            <a:lvl8pPr marL="3200400" indent="0">
-              <a:buNone/>
-              <a:defRPr sz="1000"/>
+            <a:lvl8pPr marL="1890156" indent="0">
+              <a:buNone/>
+              <a:defRPr sz="591"/>
             </a:lvl8pPr>
-            <a:lvl9pPr marL="3657600" indent="0">
-              <a:buNone/>
-              <a:defRPr sz="1000"/>
+            <a:lvl9pPr marL="2160179" indent="0">
+              <a:buNone/>
+              <a:defRPr sz="591"/>
             </a:lvl9pPr>
           </a:lstStyle>
           <a:p>
@@ -2372,13 +2120,7 @@
       </p:sp>
       <p:sp>
         <p:nvSpPr>
-          <p:cNvPr id="5" name="Date Placeholder 4">
-            <a:extLst>
-              <a:ext uri="{FF2B5EF4-FFF2-40B4-BE49-F238E27FC236}">
-                <a16:creationId xmlns:a16="http://schemas.microsoft.com/office/drawing/2014/main" id="{F6D60C1A-C945-E4CF-9593-042297A6438E}"/>
-              </a:ext>
-            </a:extLst>
-          </p:cNvPr>
+          <p:cNvPr id="5" name="Date Placeholder 4"/>
           <p:cNvSpPr>
             <a:spLocks noGrp="1"/>
           </p:cNvSpPr>
@@ -2393,7 +2135,7 @@
           <a:p>
             <a:fld id="{02A1A179-2826-B94E-B378-7E45598DB11F}" type="datetimeFigureOut">
               <a:rPr lang="en-NL" smtClean="0"/>
-              <a:t>27/07/2026</a:t>
+              <a:t>28/07/2026</a:t>
             </a:fld>
             <a:endParaRPr lang="en-NL"/>
           </a:p>
@@ -2401,13 +2143,7 @@
       </p:sp>
       <p:sp>
         <p:nvSpPr>
-          <p:cNvPr id="6" name="Footer Placeholder 5">
-            <a:extLst>
-              <a:ext uri="{FF2B5EF4-FFF2-40B4-BE49-F238E27FC236}">
-                <a16:creationId xmlns:a16="http://schemas.microsoft.com/office/drawing/2014/main" id="{F4D7ACBC-0999-780E-3F8A-8D39628E7B6A}"/>
-              </a:ext>
-            </a:extLst>
-          </p:cNvPr>
+          <p:cNvPr id="6" name="Footer Placeholder 5"/>
           <p:cNvSpPr>
             <a:spLocks noGrp="1"/>
           </p:cNvSpPr>
@@ -2426,13 +2162,7 @@
       </p:sp>
       <p:sp>
         <p:nvSpPr>
-          <p:cNvPr id="7" name="Slide Number Placeholder 6">
-            <a:extLst>
-              <a:ext uri="{FF2B5EF4-FFF2-40B4-BE49-F238E27FC236}">
-                <a16:creationId xmlns:a16="http://schemas.microsoft.com/office/drawing/2014/main" id="{14D04625-0874-E814-14A0-9DA85325BBA7}"/>
-              </a:ext>
-            </a:extLst>
-          </p:cNvPr>
+          <p:cNvPr id="7" name="Slide Number Placeholder 6"/>
           <p:cNvSpPr>
             <a:spLocks noGrp="1"/>
           </p:cNvSpPr>
@@ -2456,7 +2186,7 @@
     </p:spTree>
     <p:extLst>
       <p:ext uri="{BB962C8B-B14F-4D97-AF65-F5344CB8AC3E}">
-        <p14:creationId xmlns:p14="http://schemas.microsoft.com/office/powerpoint/2010/main" val="598241968"/>
+        <p14:creationId xmlns:p14="http://schemas.microsoft.com/office/powerpoint/2010/main" val="1080386712"/>
       </p:ext>
     </p:extLst>
   </p:cSld>
@@ -2485,13 +2215,7 @@
       </p:grpSpPr>
       <p:sp>
         <p:nvSpPr>
-          <p:cNvPr id="2" name="Title 1">
-            <a:extLst>
-              <a:ext uri="{FF2B5EF4-FFF2-40B4-BE49-F238E27FC236}">
-                <a16:creationId xmlns:a16="http://schemas.microsoft.com/office/drawing/2014/main" id="{341111D3-DEDD-1E8B-C8AA-E8E7688D5683}"/>
-              </a:ext>
-            </a:extLst>
-          </p:cNvPr>
+          <p:cNvPr id="2" name="Title 1"/>
           <p:cNvSpPr>
             <a:spLocks noGrp="1"/>
           </p:cNvSpPr>
@@ -2501,15 +2225,15 @@
         </p:nvSpPr>
         <p:spPr>
           <a:xfrm>
-            <a:off x="839788" y="457200"/>
-            <a:ext cx="3932237" cy="1600200"/>
+            <a:off x="372000" y="336021"/>
+            <a:ext cx="1741858" cy="1176073"/>
           </a:xfrm>
         </p:spPr>
         <p:txBody>
           <a:bodyPr anchor="b"/>
           <a:lstStyle>
             <a:lvl1pPr>
-              <a:defRPr sz="3200"/>
+              <a:defRPr sz="1890"/>
             </a:lvl1pPr>
           </a:lstStyle>
           <a:p>
@@ -2517,21 +2241,15 @@
               <a:rPr lang="en-GB"/>
               <a:t>Click to edit Master title style</a:t>
             </a:r>
-            <a:endParaRPr lang="en-NL"/>
-          </a:p>
-        </p:txBody>
-      </p:sp>
-      <p:sp>
-        <p:nvSpPr>
-          <p:cNvPr id="3" name="Picture Placeholder 2">
-            <a:extLst>
-              <a:ext uri="{FF2B5EF4-FFF2-40B4-BE49-F238E27FC236}">
-                <a16:creationId xmlns:a16="http://schemas.microsoft.com/office/drawing/2014/main" id="{19EBD5C6-1F17-1464-B9BD-15A65113FFD5}"/>
-              </a:ext>
-            </a:extLst>
-          </p:cNvPr>
-          <p:cNvSpPr>
-            <a:spLocks noGrp="1"/>
+            <a:endParaRPr lang="en-US" dirty="0"/>
+          </a:p>
+        </p:txBody>
+      </p:sp>
+      <p:sp>
+        <p:nvSpPr>
+          <p:cNvPr id="3" name="Picture Placeholder 2"/>
+          <p:cNvSpPr>
+            <a:spLocks noGrp="1" noChangeAspect="1"/>
           </p:cNvSpPr>
           <p:nvPr>
             <p:ph type="pic" idx="1"/>
@@ -2539,64 +2257,62 @@
         </p:nvSpPr>
         <p:spPr>
           <a:xfrm>
-            <a:off x="5183188" y="987425"/>
-            <a:ext cx="6172200" cy="4873625"/>
+            <a:off x="2295990" y="725713"/>
+            <a:ext cx="2734092" cy="3581889"/>
           </a:xfrm>
         </p:spPr>
         <p:txBody>
-          <a:bodyPr/>
+          <a:bodyPr anchor="t"/>
           <a:lstStyle>
             <a:lvl1pPr marL="0" indent="0">
               <a:buNone/>
-              <a:defRPr sz="3200"/>
+              <a:defRPr sz="1890"/>
             </a:lvl1pPr>
-            <a:lvl2pPr marL="457200" indent="0">
-              <a:buNone/>
-              <a:defRPr sz="2800"/>
+            <a:lvl2pPr marL="270022" indent="0">
+              <a:buNone/>
+              <a:defRPr sz="1654"/>
             </a:lvl2pPr>
-            <a:lvl3pPr marL="914400" indent="0">
-              <a:buNone/>
-              <a:defRPr sz="2400"/>
+            <a:lvl3pPr marL="540045" indent="0">
+              <a:buNone/>
+              <a:defRPr sz="1417"/>
             </a:lvl3pPr>
-            <a:lvl4pPr marL="1371600" indent="0">
-              <a:buNone/>
-              <a:defRPr sz="2000"/>
+            <a:lvl4pPr marL="810067" indent="0">
+              <a:buNone/>
+              <a:defRPr sz="1181"/>
             </a:lvl4pPr>
-            <a:lvl5pPr marL="1828800" indent="0">
-              <a:buNone/>
-              <a:defRPr sz="2000"/>
+            <a:lvl5pPr marL="1080089" indent="0">
+              <a:buNone/>
+              <a:defRPr sz="1181"/>
             </a:lvl5pPr>
-            <a:lvl6pPr marL="2286000" indent="0">
-              <a:buNone/>
-              <a:defRPr sz="2000"/>
+            <a:lvl6pPr marL="1350112" indent="0">
+              <a:buNone/>
+              <a:defRPr sz="1181"/>
             </a:lvl6pPr>
-            <a:lvl7pPr marL="2743200" indent="0">
-              <a:buNone/>
-              <a:defRPr sz="2000"/>
+            <a:lvl7pPr marL="1620134" indent="0">
+              <a:buNone/>
+              <a:defRPr sz="1181"/>
             </a:lvl7pPr>
-            <a:lvl8pPr marL="3200400" indent="0">
-              <a:buNone/>
-              <a:defRPr sz="2000"/>
+            <a:lvl8pPr marL="1890156" indent="0">
+              <a:buNone/>
+              <a:defRPr sz="1181"/>
             </a:lvl8pPr>
-            <a:lvl9pPr marL="3657600" indent="0">
-              <a:buNone/>
-              <a:defRPr sz="2000"/>
+            <a:lvl9pPr marL="2160179" indent="0">
+              <a:buNone/>
+              <a:defRPr sz="1181"/>
             </a:lvl9pPr>
           </a:lstStyle>
           <a:p>
-            <a:endParaRPr lang="en-NL"/>
-          </a:p>
-        </p:txBody>
-      </p:sp>
-      <p:sp>
-        <p:nvSpPr>
-          <p:cNvPr id="4" name="Text Placeholder 3">
-            <a:extLst>
-              <a:ext uri="{FF2B5EF4-FFF2-40B4-BE49-F238E27FC236}">
-                <a16:creationId xmlns:a16="http://schemas.microsoft.com/office/drawing/2014/main" id="{4F04B203-45C2-907B-1938-1FDE9732B768}"/>
-              </a:ext>
-            </a:extLst>
-          </p:cNvPr>
+            <a:r>
+              <a:rPr lang="en-GB"/>
+              <a:t>Click icon to add picture</a:t>
+            </a:r>
+            <a:endParaRPr lang="en-US" dirty="0"/>
+          </a:p>
+        </p:txBody>
+      </p:sp>
+      <p:sp>
+        <p:nvSpPr>
+          <p:cNvPr id="4" name="Text Placeholder 3"/>
           <p:cNvSpPr>
             <a:spLocks noGrp="1"/>
           </p:cNvSpPr>
@@ -2606,8 +2322,8 @@
         </p:nvSpPr>
         <p:spPr>
           <a:xfrm>
-            <a:off x="839788" y="2057400"/>
-            <a:ext cx="3932237" cy="3811588"/>
+            <a:off x="372000" y="1512094"/>
+            <a:ext cx="1741858" cy="2801341"/>
           </a:xfrm>
         </p:spPr>
         <p:txBody>
@@ -2615,39 +2331,39 @@
           <a:lstStyle>
             <a:lvl1pPr marL="0" indent="0">
               <a:buNone/>
-              <a:defRPr sz="1600"/>
+              <a:defRPr sz="945"/>
             </a:lvl1pPr>
-            <a:lvl2pPr marL="457200" indent="0">
-              <a:buNone/>
-              <a:defRPr sz="1400"/>
+            <a:lvl2pPr marL="270022" indent="0">
+              <a:buNone/>
+              <a:defRPr sz="827"/>
             </a:lvl2pPr>
-            <a:lvl3pPr marL="914400" indent="0">
-              <a:buNone/>
-              <a:defRPr sz="1200"/>
+            <a:lvl3pPr marL="540045" indent="0">
+              <a:buNone/>
+              <a:defRPr sz="709"/>
             </a:lvl3pPr>
-            <a:lvl4pPr marL="1371600" indent="0">
-              <a:buNone/>
-              <a:defRPr sz="1000"/>
+            <a:lvl4pPr marL="810067" indent="0">
+              <a:buNone/>
+              <a:defRPr sz="591"/>
             </a:lvl4pPr>
-            <a:lvl5pPr marL="1828800" indent="0">
-              <a:buNone/>
-              <a:defRPr sz="1000"/>
+            <a:lvl5pPr marL="1080089" indent="0">
+              <a:buNone/>
+              <a:defRPr sz="591"/>
             </a:lvl5pPr>
-            <a:lvl6pPr marL="2286000" indent="0">
-              <a:buNone/>
-              <a:defRPr sz="1000"/>
+            <a:lvl6pPr marL="1350112" indent="0">
+              <a:buNone/>
+              <a:defRPr sz="591"/>
             </a:lvl6pPr>
-            <a:lvl7pPr marL="2743200" indent="0">
-              <a:buNone/>
-              <a:defRPr sz="1000"/>
+            <a:lvl7pPr marL="1620134" indent="0">
+              <a:buNone/>
+              <a:defRPr sz="591"/>
             </a:lvl7pPr>
-            <a:lvl8pPr marL="3200400" indent="0">
-              <a:buNone/>
-              <a:defRPr sz="1000"/>
+            <a:lvl8pPr marL="1890156" indent="0">
+              <a:buNone/>
+              <a:defRPr sz="591"/>
             </a:lvl8pPr>
-            <a:lvl9pPr marL="3657600" indent="0">
-              <a:buNone/>
-              <a:defRPr sz="1000"/>
+            <a:lvl9pPr marL="2160179" indent="0">
+              <a:buNone/>
+              <a:defRPr sz="591"/>
             </a:lvl9pPr>
           </a:lstStyle>
           <a:p>
@@ -2661,13 +2377,7 @@
       </p:sp>
       <p:sp>
         <p:nvSpPr>
-          <p:cNvPr id="5" name="Date Placeholder 4">
-            <a:extLst>
-              <a:ext uri="{FF2B5EF4-FFF2-40B4-BE49-F238E27FC236}">
-                <a16:creationId xmlns:a16="http://schemas.microsoft.com/office/drawing/2014/main" id="{1DED89CD-63B2-6EFD-BFD4-33EEB35811E7}"/>
-              </a:ext>
-            </a:extLst>
-          </p:cNvPr>
+          <p:cNvPr id="5" name="Date Placeholder 4"/>
           <p:cNvSpPr>
             <a:spLocks noGrp="1"/>
           </p:cNvSpPr>
@@ -2682,7 +2392,7 @@
           <a:p>
             <a:fld id="{02A1A179-2826-B94E-B378-7E45598DB11F}" type="datetimeFigureOut">
               <a:rPr lang="en-NL" smtClean="0"/>
-              <a:t>27/07/2026</a:t>
+              <a:t>28/07/2026</a:t>
             </a:fld>
             <a:endParaRPr lang="en-NL"/>
           </a:p>
@@ -2690,13 +2400,7 @@
       </p:sp>
       <p:sp>
         <p:nvSpPr>
-          <p:cNvPr id="6" name="Footer Placeholder 5">
-            <a:extLst>
-              <a:ext uri="{FF2B5EF4-FFF2-40B4-BE49-F238E27FC236}">
-                <a16:creationId xmlns:a16="http://schemas.microsoft.com/office/drawing/2014/main" id="{9E984E3E-0CDC-C81A-6EB5-0FF3FEB4E6D1}"/>
-              </a:ext>
-            </a:extLst>
-          </p:cNvPr>
+          <p:cNvPr id="6" name="Footer Placeholder 5"/>
           <p:cNvSpPr>
             <a:spLocks noGrp="1"/>
           </p:cNvSpPr>
@@ -2715,13 +2419,7 @@
       </p:sp>
       <p:sp>
         <p:nvSpPr>
-          <p:cNvPr id="7" name="Slide Number Placeholder 6">
-            <a:extLst>
-              <a:ext uri="{FF2B5EF4-FFF2-40B4-BE49-F238E27FC236}">
-                <a16:creationId xmlns:a16="http://schemas.microsoft.com/office/drawing/2014/main" id="{2C78A9D2-3B21-95B2-4E80-A4626728610A}"/>
-              </a:ext>
-            </a:extLst>
-          </p:cNvPr>
+          <p:cNvPr id="7" name="Slide Number Placeholder 6"/>
           <p:cNvSpPr>
             <a:spLocks noGrp="1"/>
           </p:cNvSpPr>
@@ -2745,7 +2443,7 @@
     </p:spTree>
     <p:extLst>
       <p:ext uri="{BB962C8B-B14F-4D97-AF65-F5344CB8AC3E}">
-        <p14:creationId xmlns:p14="http://schemas.microsoft.com/office/powerpoint/2010/main" val="3849653214"/>
+        <p14:creationId xmlns:p14="http://schemas.microsoft.com/office/powerpoint/2010/main" val="2603797334"/>
       </p:ext>
     </p:extLst>
   </p:cSld>
@@ -2779,13 +2477,7 @@
       </p:grpSpPr>
       <p:sp>
         <p:nvSpPr>
-          <p:cNvPr id="2" name="Title Placeholder 1">
-            <a:extLst>
-              <a:ext uri="{FF2B5EF4-FFF2-40B4-BE49-F238E27FC236}">
-                <a16:creationId xmlns:a16="http://schemas.microsoft.com/office/drawing/2014/main" id="{0EE25186-63E4-E4D0-5AB2-013956EFEA0A}"/>
-              </a:ext>
-            </a:extLst>
-          </p:cNvPr>
+          <p:cNvPr id="2" name="Title Placeholder 1"/>
           <p:cNvSpPr>
             <a:spLocks noGrp="1"/>
           </p:cNvSpPr>
@@ -2795,8 +2487,8 @@
         </p:nvSpPr>
         <p:spPr>
           <a:xfrm>
-            <a:off x="838200" y="365125"/>
-            <a:ext cx="10515600" cy="1325563"/>
+            <a:off x="371297" y="268351"/>
+            <a:ext cx="4658082" cy="974228"/>
           </a:xfrm>
           <a:prstGeom prst="rect">
             <a:avLst/>
@@ -2812,19 +2504,13 @@
               <a:rPr lang="en-GB"/>
               <a:t>Click to edit Master title style</a:t>
             </a:r>
-            <a:endParaRPr lang="en-NL"/>
-          </a:p>
-        </p:txBody>
-      </p:sp>
-      <p:sp>
-        <p:nvSpPr>
-          <p:cNvPr id="3" name="Text Placeholder 2">
-            <a:extLst>
-              <a:ext uri="{FF2B5EF4-FFF2-40B4-BE49-F238E27FC236}">
-                <a16:creationId xmlns:a16="http://schemas.microsoft.com/office/drawing/2014/main" id="{44E004F2-1B30-5EFE-ECFB-02C7EBB01D20}"/>
-              </a:ext>
-            </a:extLst>
-          </p:cNvPr>
+            <a:endParaRPr lang="en-US" dirty="0"/>
+          </a:p>
+        </p:txBody>
+      </p:sp>
+      <p:sp>
+        <p:nvSpPr>
+          <p:cNvPr id="3" name="Text Placeholder 2"/>
           <p:cNvSpPr>
             <a:spLocks noGrp="1"/>
           </p:cNvSpPr>
@@ -2834,8 +2520,8 @@
         </p:nvSpPr>
         <p:spPr>
           <a:xfrm>
-            <a:off x="838200" y="1825625"/>
-            <a:ext cx="10515600" cy="4351338"/>
+            <a:off x="371297" y="1341750"/>
+            <a:ext cx="4658082" cy="3198032"/>
           </a:xfrm>
           <a:prstGeom prst="rect">
             <a:avLst/>
@@ -2880,19 +2566,13 @@
               <a:rPr lang="en-GB"/>
               <a:t>Fifth level</a:t>
             </a:r>
-            <a:endParaRPr lang="en-NL"/>
-          </a:p>
-        </p:txBody>
-      </p:sp>
-      <p:sp>
-        <p:nvSpPr>
-          <p:cNvPr id="4" name="Date Placeholder 3">
-            <a:extLst>
-              <a:ext uri="{FF2B5EF4-FFF2-40B4-BE49-F238E27FC236}">
-                <a16:creationId xmlns:a16="http://schemas.microsoft.com/office/drawing/2014/main" id="{9BFC10BF-D411-4733-3EFD-3F46ABA54F25}"/>
-              </a:ext>
-            </a:extLst>
-          </p:cNvPr>
+            <a:endParaRPr lang="en-US" dirty="0"/>
+          </a:p>
+        </p:txBody>
+      </p:sp>
+      <p:sp>
+        <p:nvSpPr>
+          <p:cNvPr id="4" name="Date Placeholder 3"/>
           <p:cNvSpPr>
             <a:spLocks noGrp="1"/>
           </p:cNvSpPr>
@@ -2902,8 +2582,8 @@
         </p:nvSpPr>
         <p:spPr>
           <a:xfrm>
-            <a:off x="838200" y="6356350"/>
-            <a:ext cx="2743200" cy="365125"/>
+            <a:off x="371296" y="4671625"/>
+            <a:ext cx="1215152" cy="268350"/>
           </a:xfrm>
           <a:prstGeom prst="rect">
             <a:avLst/>
@@ -2913,7 +2593,7 @@
           <a:bodyPr vert="horz" lIns="91440" tIns="45720" rIns="91440" bIns="45720" rtlCol="0" anchor="ctr"/>
           <a:lstStyle>
             <a:lvl1pPr algn="l">
-              <a:defRPr sz="1200">
+              <a:defRPr sz="709">
                 <a:solidFill>
                   <a:schemeClr val="tx1">
                     <a:tint val="82000"/>
@@ -2925,7 +2605,7 @@
           <a:p>
             <a:fld id="{02A1A179-2826-B94E-B378-7E45598DB11F}" type="datetimeFigureOut">
               <a:rPr lang="en-NL" smtClean="0"/>
-              <a:t>27/07/2026</a:t>
+              <a:t>28/07/2026</a:t>
             </a:fld>
             <a:endParaRPr lang="en-NL"/>
           </a:p>
@@ -2933,13 +2613,7 @@
       </p:sp>
       <p:sp>
         <p:nvSpPr>
-          <p:cNvPr id="5" name="Footer Placeholder 4">
-            <a:extLst>
-              <a:ext uri="{FF2B5EF4-FFF2-40B4-BE49-F238E27FC236}">
-                <a16:creationId xmlns:a16="http://schemas.microsoft.com/office/drawing/2014/main" id="{8A7DB6A4-C922-E0F4-7872-62B1854C193A}"/>
-              </a:ext>
-            </a:extLst>
-          </p:cNvPr>
+          <p:cNvPr id="5" name="Footer Placeholder 4"/>
           <p:cNvSpPr>
             <a:spLocks noGrp="1"/>
           </p:cNvSpPr>
@@ -2949,8 +2623,8 @@
         </p:nvSpPr>
         <p:spPr>
           <a:xfrm>
-            <a:off x="4038600" y="6356350"/>
-            <a:ext cx="4114800" cy="365125"/>
+            <a:off x="1788974" y="4671625"/>
+            <a:ext cx="1822728" cy="268350"/>
           </a:xfrm>
           <a:prstGeom prst="rect">
             <a:avLst/>
@@ -2960,7 +2634,7 @@
           <a:bodyPr vert="horz" lIns="91440" tIns="45720" rIns="91440" bIns="45720" rtlCol="0" anchor="ctr"/>
           <a:lstStyle>
             <a:lvl1pPr algn="ctr">
-              <a:defRPr sz="1200">
+              <a:defRPr sz="709">
                 <a:solidFill>
                   <a:schemeClr val="tx1">
                     <a:tint val="82000"/>
@@ -2976,13 +2650,7 @@
       </p:sp>
       <p:sp>
         <p:nvSpPr>
-          <p:cNvPr id="6" name="Slide Number Placeholder 5">
-            <a:extLst>
-              <a:ext uri="{FF2B5EF4-FFF2-40B4-BE49-F238E27FC236}">
-                <a16:creationId xmlns:a16="http://schemas.microsoft.com/office/drawing/2014/main" id="{511975AE-5B3F-90A2-4081-5A6348EA53D1}"/>
-              </a:ext>
-            </a:extLst>
-          </p:cNvPr>
+          <p:cNvPr id="6" name="Slide Number Placeholder 5"/>
           <p:cNvSpPr>
             <a:spLocks noGrp="1"/>
           </p:cNvSpPr>
@@ -2992,8 +2660,8 @@
         </p:nvSpPr>
         <p:spPr>
           <a:xfrm>
-            <a:off x="8610600" y="6356350"/>
-            <a:ext cx="2743200" cy="365125"/>
+            <a:off x="3814227" y="4671625"/>
+            <a:ext cx="1215152" cy="268350"/>
           </a:xfrm>
           <a:prstGeom prst="rect">
             <a:avLst/>
@@ -3003,7 +2671,7 @@
           <a:bodyPr vert="horz" lIns="91440" tIns="45720" rIns="91440" bIns="45720" rtlCol="0" anchor="ctr"/>
           <a:lstStyle>
             <a:lvl1pPr algn="r">
-              <a:defRPr sz="1200">
+              <a:defRPr sz="709">
                 <a:solidFill>
                   <a:schemeClr val="tx1">
                     <a:tint val="82000"/>
@@ -3024,27 +2692,27 @@
     </p:spTree>
     <p:extLst>
       <p:ext uri="{BB962C8B-B14F-4D97-AF65-F5344CB8AC3E}">
-        <p14:creationId xmlns:p14="http://schemas.microsoft.com/office/powerpoint/2010/main" val="2102335900"/>
+        <p14:creationId xmlns:p14="http://schemas.microsoft.com/office/powerpoint/2010/main" val="3691792129"/>
       </p:ext>
     </p:extLst>
   </p:cSld>
   <p:clrMap bg1="lt1" tx1="dk1" bg2="lt2" tx2="dk2" accent1="accent1" accent2="accent2" accent3="accent3" accent4="accent4" accent5="accent5" accent6="accent6" hlink="hlink" folHlink="folHlink"/>
   <p:sldLayoutIdLst>
-    <p:sldLayoutId id="2147483649" r:id="rId1"/>
-    <p:sldLayoutId id="2147483650" r:id="rId2"/>
-    <p:sldLayoutId id="2147483651" r:id="rId3"/>
-    <p:sldLayoutId id="2147483652" r:id="rId4"/>
-    <p:sldLayoutId id="2147483653" r:id="rId5"/>
-    <p:sldLayoutId id="2147483654" r:id="rId6"/>
-    <p:sldLayoutId id="2147483655" r:id="rId7"/>
-    <p:sldLayoutId id="2147483656" r:id="rId8"/>
-    <p:sldLayoutId id="2147483657" r:id="rId9"/>
-    <p:sldLayoutId id="2147483658" r:id="rId10"/>
-    <p:sldLayoutId id="2147483659" r:id="rId11"/>
+    <p:sldLayoutId id="2147483721" r:id="rId1"/>
+    <p:sldLayoutId id="2147483722" r:id="rId2"/>
+    <p:sldLayoutId id="2147483723" r:id="rId3"/>
+    <p:sldLayoutId id="2147483724" r:id="rId4"/>
+    <p:sldLayoutId id="2147483725" r:id="rId5"/>
+    <p:sldLayoutId id="2147483726" r:id="rId6"/>
+    <p:sldLayoutId id="2147483727" r:id="rId7"/>
+    <p:sldLayoutId id="2147483728" r:id="rId8"/>
+    <p:sldLayoutId id="2147483729" r:id="rId9"/>
+    <p:sldLayoutId id="2147483730" r:id="rId10"/>
+    <p:sldLayoutId id="2147483731" r:id="rId11"/>
   </p:sldLayoutIdLst>
   <p:txStyles>
     <p:titleStyle>
-      <a:lvl1pPr algn="l" defTabSz="914400" rtl="0" eaLnBrk="1" latinLnBrk="0" hangingPunct="1">
+      <a:lvl1pPr algn="l" defTabSz="540045" rtl="0" eaLnBrk="1" latinLnBrk="0" hangingPunct="1">
         <a:lnSpc>
           <a:spcPct val="90000"/>
         </a:lnSpc>
@@ -3052,7 +2720,7 @@
           <a:spcPct val="0"/>
         </a:spcBef>
         <a:buNone/>
-        <a:defRPr sz="4400" kern="1200">
+        <a:defRPr sz="2599" kern="1200">
           <a:solidFill>
             <a:schemeClr val="tx1"/>
           </a:solidFill>
@@ -3063,16 +2731,16 @@
       </a:lvl1pPr>
     </p:titleStyle>
     <p:bodyStyle>
-      <a:lvl1pPr marL="228600" indent="-228600" algn="l" defTabSz="914400" rtl="0" eaLnBrk="1" latinLnBrk="0" hangingPunct="1">
+      <a:lvl1pPr marL="135011" indent="-135011" algn="l" defTabSz="540045" rtl="0" eaLnBrk="1" latinLnBrk="0" hangingPunct="1">
         <a:lnSpc>
           <a:spcPct val="90000"/>
         </a:lnSpc>
         <a:spcBef>
-          <a:spcPts val="1000"/>
+          <a:spcPts val="591"/>
         </a:spcBef>
         <a:buFont typeface="Arial" panose="020B0604020202020204" pitchFamily="34" charset="0"/>
         <a:buChar char="•"/>
-        <a:defRPr sz="2800" kern="1200">
+        <a:defRPr sz="1654" kern="1200">
           <a:solidFill>
             <a:schemeClr val="tx1"/>
           </a:solidFill>
@@ -3081,16 +2749,16 @@
           <a:cs typeface="+mn-cs"/>
         </a:defRPr>
       </a:lvl1pPr>
-      <a:lvl2pPr marL="685800" indent="-228600" algn="l" defTabSz="914400" rtl="0" eaLnBrk="1" latinLnBrk="0" hangingPunct="1">
+      <a:lvl2pPr marL="405033" indent="-135011" algn="l" defTabSz="540045" rtl="0" eaLnBrk="1" latinLnBrk="0" hangingPunct="1">
         <a:lnSpc>
           <a:spcPct val="90000"/>
         </a:lnSpc>
         <a:spcBef>
-          <a:spcPts val="500"/>
+          <a:spcPts val="295"/>
         </a:spcBef>
         <a:buFont typeface="Arial" panose="020B0604020202020204" pitchFamily="34" charset="0"/>
         <a:buChar char="•"/>
-        <a:defRPr sz="2400" kern="1200">
+        <a:defRPr sz="1417" kern="1200">
           <a:solidFill>
             <a:schemeClr val="tx1"/>
           </a:solidFill>
@@ -3099,16 +2767,16 @@
           <a:cs typeface="+mn-cs"/>
         </a:defRPr>
       </a:lvl2pPr>
-      <a:lvl3pPr marL="1143000" indent="-228600" algn="l" defTabSz="914400" rtl="0" eaLnBrk="1" latinLnBrk="0" hangingPunct="1">
+      <a:lvl3pPr marL="675056" indent="-135011" algn="l" defTabSz="540045" rtl="0" eaLnBrk="1" latinLnBrk="0" hangingPunct="1">
         <a:lnSpc>
           <a:spcPct val="90000"/>
         </a:lnSpc>
         <a:spcBef>
-          <a:spcPts val="500"/>
+          <a:spcPts val="295"/>
         </a:spcBef>
         <a:buFont typeface="Arial" panose="020B0604020202020204" pitchFamily="34" charset="0"/>
         <a:buChar char="•"/>
-        <a:defRPr sz="2000" kern="1200">
+        <a:defRPr sz="1181" kern="1200">
           <a:solidFill>
             <a:schemeClr val="tx1"/>
           </a:solidFill>
@@ -3117,16 +2785,16 @@
           <a:cs typeface="+mn-cs"/>
         </a:defRPr>
       </a:lvl3pPr>
-      <a:lvl4pPr marL="1600200" indent="-228600" algn="l" defTabSz="914400" rtl="0" eaLnBrk="1" latinLnBrk="0" hangingPunct="1">
+      <a:lvl4pPr marL="945078" indent="-135011" algn="l" defTabSz="540045" rtl="0" eaLnBrk="1" latinLnBrk="0" hangingPunct="1">
         <a:lnSpc>
           <a:spcPct val="90000"/>
         </a:lnSpc>
         <a:spcBef>
-          <a:spcPts val="500"/>
+          <a:spcPts val="295"/>
         </a:spcBef>
         <a:buFont typeface="Arial" panose="020B0604020202020204" pitchFamily="34" charset="0"/>
         <a:buChar char="•"/>
-        <a:defRPr sz="1800" kern="1200">
+        <a:defRPr sz="1063" kern="1200">
           <a:solidFill>
             <a:schemeClr val="tx1"/>
           </a:solidFill>
@@ -3135,16 +2803,16 @@
           <a:cs typeface="+mn-cs"/>
         </a:defRPr>
       </a:lvl4pPr>
-      <a:lvl5pPr marL="2057400" indent="-228600" algn="l" defTabSz="914400" rtl="0" eaLnBrk="1" latinLnBrk="0" hangingPunct="1">
+      <a:lvl5pPr marL="1215100" indent="-135011" algn="l" defTabSz="540045" rtl="0" eaLnBrk="1" latinLnBrk="0" hangingPunct="1">
         <a:lnSpc>
           <a:spcPct val="90000"/>
         </a:lnSpc>
         <a:spcBef>
-          <a:spcPts val="500"/>
+          <a:spcPts val="295"/>
         </a:spcBef>
         <a:buFont typeface="Arial" panose="020B0604020202020204" pitchFamily="34" charset="0"/>
         <a:buChar char="•"/>
-        <a:defRPr sz="1800" kern="1200">
+        <a:defRPr sz="1063" kern="1200">
           <a:solidFill>
             <a:schemeClr val="tx1"/>
           </a:solidFill>
@@ -3153,16 +2821,16 @@
           <a:cs typeface="+mn-cs"/>
         </a:defRPr>
       </a:lvl5pPr>
-      <a:lvl6pPr marL="2514600" indent="-228600" algn="l" defTabSz="914400" rtl="0" eaLnBrk="1" latinLnBrk="0" hangingPunct="1">
+      <a:lvl6pPr marL="1485123" indent="-135011" algn="l" defTabSz="540045" rtl="0" eaLnBrk="1" latinLnBrk="0" hangingPunct="1">
         <a:lnSpc>
           <a:spcPct val="90000"/>
         </a:lnSpc>
         <a:spcBef>
-          <a:spcPts val="500"/>
+          <a:spcPts val="295"/>
         </a:spcBef>
         <a:buFont typeface="Arial" panose="020B0604020202020204" pitchFamily="34" charset="0"/>
         <a:buChar char="•"/>
-        <a:defRPr sz="1800" kern="1200">
+        <a:defRPr sz="1063" kern="1200">
           <a:solidFill>
             <a:schemeClr val="tx1"/>
           </a:solidFill>
@@ -3171,16 +2839,16 @@
           <a:cs typeface="+mn-cs"/>
         </a:defRPr>
       </a:lvl6pPr>
-      <a:lvl7pPr marL="2971800" indent="-228600" algn="l" defTabSz="914400" rtl="0" eaLnBrk="1" latinLnBrk="0" hangingPunct="1">
+      <a:lvl7pPr marL="1755145" indent="-135011" algn="l" defTabSz="540045" rtl="0" eaLnBrk="1" latinLnBrk="0" hangingPunct="1">
         <a:lnSpc>
           <a:spcPct val="90000"/>
         </a:lnSpc>
         <a:spcBef>
-          <a:spcPts val="500"/>
+          <a:spcPts val="295"/>
         </a:spcBef>
         <a:buFont typeface="Arial" panose="020B0604020202020204" pitchFamily="34" charset="0"/>
         <a:buChar char="•"/>
-        <a:defRPr sz="1800" kern="1200">
+        <a:defRPr sz="1063" kern="1200">
           <a:solidFill>
             <a:schemeClr val="tx1"/>
           </a:solidFill>
@@ -3189,16 +2857,16 @@
           <a:cs typeface="+mn-cs"/>
         </a:defRPr>
       </a:lvl7pPr>
-      <a:lvl8pPr marL="3429000" indent="-228600" algn="l" defTabSz="914400" rtl="0" eaLnBrk="1" latinLnBrk="0" hangingPunct="1">
+      <a:lvl8pPr marL="2025167" indent="-135011" algn="l" defTabSz="540045" rtl="0" eaLnBrk="1" latinLnBrk="0" hangingPunct="1">
         <a:lnSpc>
           <a:spcPct val="90000"/>
         </a:lnSpc>
         <a:spcBef>
-          <a:spcPts val="500"/>
+          <a:spcPts val="295"/>
         </a:spcBef>
         <a:buFont typeface="Arial" panose="020B0604020202020204" pitchFamily="34" charset="0"/>
         <a:buChar char="•"/>
-        <a:defRPr sz="1800" kern="1200">
+        <a:defRPr sz="1063" kern="1200">
           <a:solidFill>
             <a:schemeClr val="tx1"/>
           </a:solidFill>
@@ -3207,16 +2875,16 @@
           <a:cs typeface="+mn-cs"/>
         </a:defRPr>
       </a:lvl8pPr>
-      <a:lvl9pPr marL="3886200" indent="-228600" algn="l" defTabSz="914400" rtl="0" eaLnBrk="1" latinLnBrk="0" hangingPunct="1">
+      <a:lvl9pPr marL="2295190" indent="-135011" algn="l" defTabSz="540045" rtl="0" eaLnBrk="1" latinLnBrk="0" hangingPunct="1">
         <a:lnSpc>
           <a:spcPct val="90000"/>
         </a:lnSpc>
         <a:spcBef>
-          <a:spcPts val="500"/>
+          <a:spcPts val="295"/>
         </a:spcBef>
         <a:buFont typeface="Arial" panose="020B0604020202020204" pitchFamily="34" charset="0"/>
         <a:buChar char="•"/>
-        <a:defRPr sz="1800" kern="1200">
+        <a:defRPr sz="1063" kern="1200">
           <a:solidFill>
             <a:schemeClr val="tx1"/>
           </a:solidFill>
@@ -3228,10 +2896,10 @@
     </p:bodyStyle>
     <p:otherStyle>
       <a:defPPr>
-        <a:defRPr lang="en-NL"/>
+        <a:defRPr lang="en-US"/>
       </a:defPPr>
-      <a:lvl1pPr marL="0" algn="l" defTabSz="914400" rtl="0" eaLnBrk="1" latinLnBrk="0" hangingPunct="1">
-        <a:defRPr sz="1800" kern="1200">
+      <a:lvl1pPr marL="0" algn="l" defTabSz="540045" rtl="0" eaLnBrk="1" latinLnBrk="0" hangingPunct="1">
+        <a:defRPr sz="1063" kern="1200">
           <a:solidFill>
             <a:schemeClr val="tx1"/>
           </a:solidFill>
@@ -3240,8 +2908,8 @@
           <a:cs typeface="+mn-cs"/>
         </a:defRPr>
       </a:lvl1pPr>
-      <a:lvl2pPr marL="457200" algn="l" defTabSz="914400" rtl="0" eaLnBrk="1" latinLnBrk="0" hangingPunct="1">
-        <a:defRPr sz="1800" kern="1200">
+      <a:lvl2pPr marL="270022" algn="l" defTabSz="540045" rtl="0" eaLnBrk="1" latinLnBrk="0" hangingPunct="1">
+        <a:defRPr sz="1063" kern="1200">
           <a:solidFill>
             <a:schemeClr val="tx1"/>
           </a:solidFill>
@@ -3250,8 +2918,8 @@
           <a:cs typeface="+mn-cs"/>
         </a:defRPr>
       </a:lvl2pPr>
-      <a:lvl3pPr marL="914400" algn="l" defTabSz="914400" rtl="0" eaLnBrk="1" latinLnBrk="0" hangingPunct="1">
-        <a:defRPr sz="1800" kern="1200">
+      <a:lvl3pPr marL="540045" algn="l" defTabSz="540045" rtl="0" eaLnBrk="1" latinLnBrk="0" hangingPunct="1">
+        <a:defRPr sz="1063" kern="1200">
           <a:solidFill>
             <a:schemeClr val="tx1"/>
           </a:solidFill>
@@ -3260,8 +2928,8 @@
           <a:cs typeface="+mn-cs"/>
         </a:defRPr>
       </a:lvl3pPr>
-      <a:lvl4pPr marL="1371600" algn="l" defTabSz="914400" rtl="0" eaLnBrk="1" latinLnBrk="0" hangingPunct="1">
-        <a:defRPr sz="1800" kern="1200">
+      <a:lvl4pPr marL="810067" algn="l" defTabSz="540045" rtl="0" eaLnBrk="1" latinLnBrk="0" hangingPunct="1">
+        <a:defRPr sz="1063" kern="1200">
           <a:solidFill>
             <a:schemeClr val="tx1"/>
           </a:solidFill>
@@ -3270,8 +2938,8 @@
           <a:cs typeface="+mn-cs"/>
         </a:defRPr>
       </a:lvl4pPr>
-      <a:lvl5pPr marL="1828800" algn="l" defTabSz="914400" rtl="0" eaLnBrk="1" latinLnBrk="0" hangingPunct="1">
-        <a:defRPr sz="1800" kern="1200">
+      <a:lvl5pPr marL="1080089" algn="l" defTabSz="540045" rtl="0" eaLnBrk="1" latinLnBrk="0" hangingPunct="1">
+        <a:defRPr sz="1063" kern="1200">
           <a:solidFill>
             <a:schemeClr val="tx1"/>
           </a:solidFill>
@@ -3280,8 +2948,8 @@
           <a:cs typeface="+mn-cs"/>
         </a:defRPr>
       </a:lvl5pPr>
-      <a:lvl6pPr marL="2286000" algn="l" defTabSz="914400" rtl="0" eaLnBrk="1" latinLnBrk="0" hangingPunct="1">
-        <a:defRPr sz="1800" kern="1200">
+      <a:lvl6pPr marL="1350112" algn="l" defTabSz="540045" rtl="0" eaLnBrk="1" latinLnBrk="0" hangingPunct="1">
+        <a:defRPr sz="1063" kern="1200">
           <a:solidFill>
             <a:schemeClr val="tx1"/>
           </a:solidFill>
@@ -3290,8 +2958,8 @@
           <a:cs typeface="+mn-cs"/>
         </a:defRPr>
       </a:lvl6pPr>
-      <a:lvl7pPr marL="2743200" algn="l" defTabSz="914400" rtl="0" eaLnBrk="1" latinLnBrk="0" hangingPunct="1">
-        <a:defRPr sz="1800" kern="1200">
+      <a:lvl7pPr marL="1620134" algn="l" defTabSz="540045" rtl="0" eaLnBrk="1" latinLnBrk="0" hangingPunct="1">
+        <a:defRPr sz="1063" kern="1200">
           <a:solidFill>
             <a:schemeClr val="tx1"/>
           </a:solidFill>
@@ -3300,8 +2968,8 @@
           <a:cs typeface="+mn-cs"/>
         </a:defRPr>
       </a:lvl7pPr>
-      <a:lvl8pPr marL="3200400" algn="l" defTabSz="914400" rtl="0" eaLnBrk="1" latinLnBrk="0" hangingPunct="1">
-        <a:defRPr sz="1800" kern="1200">
+      <a:lvl8pPr marL="1890156" algn="l" defTabSz="540045" rtl="0" eaLnBrk="1" latinLnBrk="0" hangingPunct="1">
+        <a:defRPr sz="1063" kern="1200">
           <a:solidFill>
             <a:schemeClr val="tx1"/>
           </a:solidFill>
@@ -3310,8 +2978,8 @@
           <a:cs typeface="+mn-cs"/>
         </a:defRPr>
       </a:lvl8pPr>
-      <a:lvl9pPr marL="3657600" algn="l" defTabSz="914400" rtl="0" eaLnBrk="1" latinLnBrk="0" hangingPunct="1">
-        <a:defRPr sz="1800" kern="1200">
+      <a:lvl9pPr marL="2160179" algn="l" defTabSz="540045" rtl="0" eaLnBrk="1" latinLnBrk="0" hangingPunct="1">
+        <a:defRPr sz="1063" kern="1200">
           <a:solidFill>
             <a:schemeClr val="tx1"/>
           </a:solidFill>
@@ -3342,472 +3010,493 @@
           <a:chExt cx="0" cy="0"/>
         </a:xfrm>
       </p:grpSpPr>
-      <p:sp>
-        <p:nvSpPr>
-          <p:cNvPr id="7" name="Rounded Rectangle 6">
+      <p:grpSp>
+        <p:nvGrpSpPr>
+          <p:cNvPr id="8" name="Group 7">
             <a:extLst>
               <a:ext uri="{FF2B5EF4-FFF2-40B4-BE49-F238E27FC236}">
-                <a16:creationId xmlns:a16="http://schemas.microsoft.com/office/drawing/2014/main" id="{3EA8E2D3-94DA-0E1C-F3A4-7B427B739E16}"/>
+                <a16:creationId xmlns:a16="http://schemas.microsoft.com/office/drawing/2014/main" id="{CD9885B1-CAF3-100C-E9A1-7FD318C8B46E}"/>
               </a:ext>
             </a:extLst>
           </p:cNvPr>
-          <p:cNvSpPr/>
+          <p:cNvGrpSpPr/>
           <p:nvPr/>
-        </p:nvSpPr>
-        <p:spPr>
+        </p:nvGrpSpPr>
+        <p:grpSpPr>
           <a:xfrm>
-            <a:off x="6927380" y="1658107"/>
-            <a:ext cx="1430594" cy="3179363"/>
+            <a:off x="216530" y="270148"/>
+            <a:ext cx="4967614" cy="4490818"/>
+            <a:chOff x="3360574" y="341831"/>
+            <a:chExt cx="4967614" cy="4490818"/>
           </a:xfrm>
-          <a:prstGeom prst="roundRect">
-            <a:avLst/>
-          </a:prstGeom>
-          <a:solidFill>
-            <a:srgbClr val="F9F8F6"/>
-          </a:solidFill>
-          <a:ln>
-            <a:noFill/>
-          </a:ln>
-        </p:spPr>
-        <p:style>
-          <a:lnRef idx="2">
-            <a:schemeClr val="accent1">
-              <a:shade val="15000"/>
-            </a:schemeClr>
-          </a:lnRef>
-          <a:fillRef idx="1">
-            <a:schemeClr val="accent1"/>
-          </a:fillRef>
-          <a:effectRef idx="0">
-            <a:schemeClr val="accent1"/>
-          </a:effectRef>
-          <a:fontRef idx="minor">
-            <a:schemeClr val="lt1"/>
-          </a:fontRef>
-        </p:style>
-        <p:txBody>
-          <a:bodyPr rtlCol="0" anchor="ctr"/>
-          <a:lstStyle/>
-          <a:p>
-            <a:pPr algn="ctr"/>
-            <a:r>
-              <a:rPr lang="en-NL" sz="1000" dirty="0">
+        </p:grpSpPr>
+        <p:sp>
+          <p:nvSpPr>
+            <p:cNvPr id="7" name="Rounded Rectangle 6">
+              <a:extLst>
+                <a:ext uri="{FF2B5EF4-FFF2-40B4-BE49-F238E27FC236}">
+                  <a16:creationId xmlns:a16="http://schemas.microsoft.com/office/drawing/2014/main" id="{3EA8E2D3-94DA-0E1C-F3A4-7B427B739E16}"/>
+                </a:ext>
+              </a:extLst>
+            </p:cNvPr>
+            <p:cNvSpPr/>
+            <p:nvPr/>
+          </p:nvSpPr>
+          <p:spPr>
+            <a:xfrm>
+              <a:off x="6675761" y="1653286"/>
+              <a:ext cx="1430594" cy="3179363"/>
+            </a:xfrm>
+            <a:prstGeom prst="roundRect">
+              <a:avLst/>
+            </a:prstGeom>
+            <a:solidFill>
+              <a:srgbClr val="F9F8F6"/>
+            </a:solidFill>
+            <a:ln>
+              <a:noFill/>
+            </a:ln>
+          </p:spPr>
+          <p:style>
+            <a:lnRef idx="2">
+              <a:schemeClr val="accent1">
+                <a:shade val="15000"/>
+              </a:schemeClr>
+            </a:lnRef>
+            <a:fillRef idx="1">
+              <a:schemeClr val="accent1"/>
+            </a:fillRef>
+            <a:effectRef idx="0">
+              <a:schemeClr val="accent1"/>
+            </a:effectRef>
+            <a:fontRef idx="minor">
+              <a:schemeClr val="lt1"/>
+            </a:fontRef>
+          </p:style>
+          <p:txBody>
+            <a:bodyPr rtlCol="0" anchor="ctr"/>
+            <a:lstStyle/>
+            <a:p>
+              <a:pPr algn="ctr"/>
+              <a:r>
+                <a:rPr lang="en-NL" sz="1000" dirty="0">
+                  <a:solidFill>
+                    <a:schemeClr val="tx1"/>
+                  </a:solidFill>
+                </a:rPr>
+                <a:t>Closing Meeting</a:t>
+              </a:r>
+            </a:p>
+            <a:p>
+              <a:pPr algn="ctr"/>
+              <a:endParaRPr lang="en-NL" sz="1000" dirty="0">
                 <a:solidFill>
                   <a:schemeClr val="tx1"/>
                 </a:solidFill>
-              </a:rPr>
-              <a:t>Closing Meeting</a:t>
-            </a:r>
-          </a:p>
-          <a:p>
-            <a:pPr algn="ctr"/>
-            <a:endParaRPr lang="en-NL" sz="1000" dirty="0">
-              <a:solidFill>
-                <a:schemeClr val="tx1"/>
-              </a:solidFill>
-            </a:endParaRPr>
-          </a:p>
-          <a:p>
-            <a:pPr algn="ctr"/>
-            <a:r>
-              <a:rPr lang="en-NL" sz="1000" dirty="0">
+              </a:endParaRPr>
+            </a:p>
+            <a:p>
+              <a:pPr algn="ctr"/>
+              <a:r>
+                <a:rPr lang="en-NL" sz="1000" dirty="0">
+                  <a:solidFill>
+                    <a:schemeClr val="tx1"/>
+                  </a:solidFill>
+                </a:rPr>
+                <a:t>End Report</a:t>
+              </a:r>
+            </a:p>
+            <a:p>
+              <a:pPr algn="ctr"/>
+              <a:endParaRPr lang="en-NL" sz="1000" dirty="0">
                 <a:solidFill>
                   <a:schemeClr val="tx1"/>
                 </a:solidFill>
-              </a:rPr>
-              <a:t>End Report</a:t>
-            </a:r>
-          </a:p>
-          <a:p>
-            <a:pPr algn="ctr"/>
-            <a:endParaRPr lang="en-NL" sz="1000" dirty="0">
-              <a:solidFill>
-                <a:schemeClr val="tx1"/>
-              </a:solidFill>
-            </a:endParaRPr>
-          </a:p>
-        </p:txBody>
-      </p:sp>
-      <p:sp>
-        <p:nvSpPr>
-          <p:cNvPr id="6" name="Rounded Rectangle 5">
-            <a:extLst>
-              <a:ext uri="{FF2B5EF4-FFF2-40B4-BE49-F238E27FC236}">
-                <a16:creationId xmlns:a16="http://schemas.microsoft.com/office/drawing/2014/main" id="{327CDBBB-1322-A5A0-FEE2-5E2EFC3CB601}"/>
-              </a:ext>
-            </a:extLst>
-          </p:cNvPr>
-          <p:cNvSpPr/>
-          <p:nvPr/>
-        </p:nvSpPr>
-        <p:spPr>
-          <a:xfrm>
-            <a:off x="5380703" y="1658107"/>
-            <a:ext cx="1430594" cy="3179363"/>
-          </a:xfrm>
-          <a:prstGeom prst="roundRect">
-            <a:avLst/>
-          </a:prstGeom>
-          <a:solidFill>
-            <a:srgbClr val="EEF2F3"/>
-          </a:solidFill>
-          <a:ln>
-            <a:noFill/>
-          </a:ln>
-        </p:spPr>
-        <p:style>
-          <a:lnRef idx="2">
-            <a:schemeClr val="accent1">
-              <a:shade val="15000"/>
-            </a:schemeClr>
-          </a:lnRef>
-          <a:fillRef idx="1">
-            <a:schemeClr val="accent1"/>
-          </a:fillRef>
-          <a:effectRef idx="0">
-            <a:schemeClr val="accent1"/>
-          </a:effectRef>
-          <a:fontRef idx="minor">
-            <a:schemeClr val="lt1"/>
-          </a:fontRef>
-        </p:style>
-        <p:txBody>
-          <a:bodyPr rtlCol="0" anchor="ctr"/>
-          <a:lstStyle/>
-          <a:p>
-            <a:pPr algn="ctr"/>
-            <a:endParaRPr lang="en-NL" sz="1000" dirty="0">
-              <a:solidFill>
-                <a:schemeClr val="tx1"/>
-              </a:solidFill>
-            </a:endParaRPr>
-          </a:p>
-          <a:p>
-            <a:pPr algn="ctr"/>
-            <a:r>
-              <a:rPr lang="en-NL" sz="1000" dirty="0">
+              </a:endParaRPr>
+            </a:p>
+          </p:txBody>
+        </p:sp>
+        <p:sp>
+          <p:nvSpPr>
+            <p:cNvPr id="6" name="Rounded Rectangle 5">
+              <a:extLst>
+                <a:ext uri="{FF2B5EF4-FFF2-40B4-BE49-F238E27FC236}">
+                  <a16:creationId xmlns:a16="http://schemas.microsoft.com/office/drawing/2014/main" id="{327CDBBB-1322-A5A0-FEE2-5E2EFC3CB601}"/>
+                </a:ext>
+              </a:extLst>
+            </p:cNvPr>
+            <p:cNvSpPr/>
+            <p:nvPr/>
+          </p:nvSpPr>
+          <p:spPr>
+            <a:xfrm>
+              <a:off x="5129084" y="1653286"/>
+              <a:ext cx="1430594" cy="3179363"/>
+            </a:xfrm>
+            <a:prstGeom prst="roundRect">
+              <a:avLst/>
+            </a:prstGeom>
+            <a:solidFill>
+              <a:srgbClr val="EEF2F3"/>
+            </a:solidFill>
+            <a:ln>
+              <a:noFill/>
+            </a:ln>
+          </p:spPr>
+          <p:style>
+            <a:lnRef idx="2">
+              <a:schemeClr val="accent1">
+                <a:shade val="15000"/>
+              </a:schemeClr>
+            </a:lnRef>
+            <a:fillRef idx="1">
+              <a:schemeClr val="accent1"/>
+            </a:fillRef>
+            <a:effectRef idx="0">
+              <a:schemeClr val="accent1"/>
+            </a:effectRef>
+            <a:fontRef idx="minor">
+              <a:schemeClr val="lt1"/>
+            </a:fontRef>
+          </p:style>
+          <p:txBody>
+            <a:bodyPr rtlCol="0" anchor="ctr"/>
+            <a:lstStyle/>
+            <a:p>
+              <a:pPr algn="ctr"/>
+              <a:endParaRPr lang="en-NL" sz="1000" dirty="0">
                 <a:solidFill>
                   <a:schemeClr val="tx1"/>
                 </a:solidFill>
-              </a:rPr>
-              <a:t>Project Development</a:t>
-            </a:r>
-          </a:p>
-          <a:p>
-            <a:pPr algn="ctr"/>
-            <a:endParaRPr lang="en-NL" sz="1000" dirty="0">
-              <a:solidFill>
-                <a:schemeClr val="tx1"/>
-              </a:solidFill>
-            </a:endParaRPr>
-          </a:p>
-          <a:p>
-            <a:pPr algn="ctr"/>
-            <a:r>
-              <a:rPr lang="en-NL" sz="1000" dirty="0">
+              </a:endParaRPr>
+            </a:p>
+            <a:p>
+              <a:pPr algn="ctr"/>
+              <a:r>
+                <a:rPr lang="en-NL" sz="1000" dirty="0">
+                  <a:solidFill>
+                    <a:schemeClr val="tx1"/>
+                  </a:solidFill>
+                </a:rPr>
+                <a:t>Project Development</a:t>
+              </a:r>
+            </a:p>
+            <a:p>
+              <a:pPr algn="ctr"/>
+              <a:endParaRPr lang="en-NL" sz="1000" dirty="0">
                 <a:solidFill>
                   <a:schemeClr val="tx1"/>
                 </a:solidFill>
-              </a:rPr>
-              <a:t>Project Meetings</a:t>
-            </a:r>
-          </a:p>
-          <a:p>
-            <a:pPr algn="ctr"/>
-            <a:endParaRPr lang="en-NL" sz="1000" dirty="0">
-              <a:solidFill>
-                <a:schemeClr val="tx1"/>
-              </a:solidFill>
-            </a:endParaRPr>
-          </a:p>
-          <a:p>
-            <a:pPr algn="ctr"/>
-            <a:r>
-              <a:rPr lang="en-NL" sz="1000" dirty="0">
+              </a:endParaRPr>
+            </a:p>
+            <a:p>
+              <a:pPr algn="ctr"/>
+              <a:r>
+                <a:rPr lang="en-NL" sz="1000" dirty="0">
+                  <a:solidFill>
+                    <a:schemeClr val="tx1"/>
+                  </a:solidFill>
+                </a:rPr>
+                <a:t>Project Meetings</a:t>
+              </a:r>
+            </a:p>
+            <a:p>
+              <a:pPr algn="ctr"/>
+              <a:endParaRPr lang="en-NL" sz="1000" dirty="0">
                 <a:solidFill>
                   <a:schemeClr val="tx1"/>
                 </a:solidFill>
-              </a:rPr>
-              <a:t>Project Log</a:t>
-            </a:r>
-          </a:p>
-          <a:p>
-            <a:pPr algn="ctr"/>
-            <a:endParaRPr lang="en-NL" sz="1000" dirty="0">
-              <a:solidFill>
-                <a:schemeClr val="tx1"/>
-              </a:solidFill>
-            </a:endParaRPr>
-          </a:p>
-          <a:p>
-            <a:pPr algn="ctr"/>
-            <a:r>
-              <a:rPr lang="en-NL" sz="1000" dirty="0">
+              </a:endParaRPr>
+            </a:p>
+            <a:p>
+              <a:pPr algn="ctr"/>
+              <a:r>
+                <a:rPr lang="en-NL" sz="1000" dirty="0">
+                  <a:solidFill>
+                    <a:schemeClr val="tx1"/>
+                  </a:solidFill>
+                </a:rPr>
+                <a:t>Project Log</a:t>
+              </a:r>
+            </a:p>
+            <a:p>
+              <a:pPr algn="ctr"/>
+              <a:endParaRPr lang="en-NL" sz="1000" dirty="0">
                 <a:solidFill>
                   <a:schemeClr val="tx1"/>
                 </a:solidFill>
-              </a:rPr>
-              <a:t>Code Quality &amp; Sustaibility</a:t>
-            </a:r>
-          </a:p>
-          <a:p>
-            <a:pPr algn="ctr"/>
-            <a:endParaRPr lang="en-NL" sz="1000" dirty="0">
-              <a:solidFill>
-                <a:schemeClr val="tx1"/>
-              </a:solidFill>
-            </a:endParaRPr>
-          </a:p>
-          <a:p>
-            <a:pPr algn="ctr"/>
-            <a:r>
-              <a:rPr lang="en-NL" sz="1000" dirty="0">
+              </a:endParaRPr>
+            </a:p>
+            <a:p>
+              <a:pPr algn="ctr"/>
+              <a:r>
+                <a:rPr lang="en-NL" sz="1000" dirty="0">
+                  <a:solidFill>
+                    <a:schemeClr val="tx1"/>
+                  </a:solidFill>
+                </a:rPr>
+                <a:t>Code Quality &amp; Sustaibility</a:t>
+              </a:r>
+            </a:p>
+            <a:p>
+              <a:pPr algn="ctr"/>
+              <a:endParaRPr lang="en-NL" sz="1000" dirty="0">
                 <a:solidFill>
                   <a:schemeClr val="tx1"/>
                 </a:solidFill>
-              </a:rPr>
-              <a:t>Knowledge Transfer</a:t>
-            </a:r>
-          </a:p>
-          <a:p>
-            <a:pPr algn="ctr"/>
-            <a:endParaRPr lang="en-NL" sz="1000" dirty="0">
-              <a:solidFill>
-                <a:schemeClr val="tx1"/>
-              </a:solidFill>
-            </a:endParaRPr>
-          </a:p>
-          <a:p>
-            <a:pPr algn="ctr"/>
-            <a:r>
-              <a:rPr lang="en-NL" sz="1000" dirty="0">
+              </a:endParaRPr>
+            </a:p>
+            <a:p>
+              <a:pPr algn="ctr"/>
+              <a:r>
+                <a:rPr lang="en-NL" sz="1000" dirty="0">
+                  <a:solidFill>
+                    <a:schemeClr val="tx1"/>
+                  </a:solidFill>
+                </a:rPr>
+                <a:t>Knowledge Transfer</a:t>
+              </a:r>
+            </a:p>
+            <a:p>
+              <a:pPr algn="ctr"/>
+              <a:endParaRPr lang="en-NL" sz="1000" dirty="0">
                 <a:solidFill>
                   <a:schemeClr val="tx1"/>
                 </a:solidFill>
-              </a:rPr>
-              <a:t>Project Review</a:t>
-            </a:r>
-          </a:p>
-        </p:txBody>
-      </p:sp>
-      <p:sp>
-        <p:nvSpPr>
-          <p:cNvPr id="5" name="Rounded Rectangle 4">
-            <a:extLst>
-              <a:ext uri="{FF2B5EF4-FFF2-40B4-BE49-F238E27FC236}">
-                <a16:creationId xmlns:a16="http://schemas.microsoft.com/office/drawing/2014/main" id="{9BF3D0E5-1B02-C86B-7FEE-054CC6955DEA}"/>
-              </a:ext>
-            </a:extLst>
-          </p:cNvPr>
-          <p:cNvSpPr/>
-          <p:nvPr/>
-        </p:nvSpPr>
-        <p:spPr>
-          <a:xfrm>
-            <a:off x="3838444" y="1658107"/>
-            <a:ext cx="1430594" cy="3179363"/>
-          </a:xfrm>
-          <a:prstGeom prst="roundRect">
-            <a:avLst/>
-          </a:prstGeom>
-          <a:solidFill>
-            <a:srgbClr val="F9F8F6"/>
-          </a:solidFill>
-          <a:ln>
-            <a:noFill/>
-          </a:ln>
-        </p:spPr>
-        <p:style>
-          <a:lnRef idx="2">
-            <a:schemeClr val="accent1">
-              <a:shade val="15000"/>
-            </a:schemeClr>
-          </a:lnRef>
-          <a:fillRef idx="1">
-            <a:schemeClr val="accent1"/>
-          </a:fillRef>
-          <a:effectRef idx="0">
-            <a:schemeClr val="accent1"/>
-          </a:effectRef>
-          <a:fontRef idx="minor">
-            <a:schemeClr val="lt1"/>
-          </a:fontRef>
-        </p:style>
-        <p:txBody>
-          <a:bodyPr rtlCol="0" anchor="ctr"/>
-          <a:lstStyle/>
-          <a:p>
-            <a:pPr algn="ctr"/>
-            <a:br>
-              <a:rPr lang="en-NL" sz="1000" dirty="0">
+              </a:endParaRPr>
+            </a:p>
+            <a:p>
+              <a:pPr algn="ctr"/>
+              <a:r>
+                <a:rPr lang="en-NL" sz="1000" dirty="0">
+                  <a:solidFill>
+                    <a:schemeClr val="tx1"/>
+                  </a:solidFill>
+                </a:rPr>
+                <a:t>Project Review</a:t>
+              </a:r>
+            </a:p>
+          </p:txBody>
+        </p:sp>
+        <p:sp>
+          <p:nvSpPr>
+            <p:cNvPr id="5" name="Rounded Rectangle 4">
+              <a:extLst>
+                <a:ext uri="{FF2B5EF4-FFF2-40B4-BE49-F238E27FC236}">
+                  <a16:creationId xmlns:a16="http://schemas.microsoft.com/office/drawing/2014/main" id="{9BF3D0E5-1B02-C86B-7FEE-054CC6955DEA}"/>
+                </a:ext>
+              </a:extLst>
+            </p:cNvPr>
+            <p:cNvSpPr/>
+            <p:nvPr/>
+          </p:nvSpPr>
+          <p:spPr>
+            <a:xfrm>
+              <a:off x="3586825" y="1653286"/>
+              <a:ext cx="1430594" cy="3179363"/>
+            </a:xfrm>
+            <a:prstGeom prst="roundRect">
+              <a:avLst/>
+            </a:prstGeom>
+            <a:solidFill>
+              <a:srgbClr val="F9F8F6"/>
+            </a:solidFill>
+            <a:ln>
+              <a:noFill/>
+            </a:ln>
+          </p:spPr>
+          <p:style>
+            <a:lnRef idx="2">
+              <a:schemeClr val="accent1">
+                <a:shade val="15000"/>
+              </a:schemeClr>
+            </a:lnRef>
+            <a:fillRef idx="1">
+              <a:schemeClr val="accent1"/>
+            </a:fillRef>
+            <a:effectRef idx="0">
+              <a:schemeClr val="accent1"/>
+            </a:effectRef>
+            <a:fontRef idx="minor">
+              <a:schemeClr val="lt1"/>
+            </a:fontRef>
+          </p:style>
+          <p:txBody>
+            <a:bodyPr rtlCol="0" anchor="ctr"/>
+            <a:lstStyle/>
+            <a:p>
+              <a:pPr algn="ctr"/>
+              <a:br>
+                <a:rPr lang="en-NL" sz="1000" dirty="0">
+                  <a:solidFill>
+                    <a:schemeClr val="tx1"/>
+                  </a:solidFill>
+                </a:rPr>
+              </a:br>
+              <a:endParaRPr lang="en-NL" sz="1000" dirty="0">
                 <a:solidFill>
                   <a:schemeClr val="tx1"/>
                 </a:solidFill>
-              </a:rPr>
-            </a:br>
-            <a:endParaRPr lang="en-NL" sz="1000" dirty="0">
-              <a:solidFill>
-                <a:schemeClr val="tx1"/>
-              </a:solidFill>
-            </a:endParaRPr>
-          </a:p>
-          <a:p>
-            <a:pPr algn="ctr"/>
-            <a:r>
-              <a:rPr lang="en-NL" sz="1000" dirty="0">
+              </a:endParaRPr>
+            </a:p>
+            <a:p>
+              <a:pPr algn="ctr"/>
+              <a:r>
+                <a:rPr lang="en-NL" sz="1000" dirty="0">
+                  <a:solidFill>
+                    <a:schemeClr val="tx1"/>
+                  </a:solidFill>
+                </a:rPr>
+                <a:t>SH Assignament</a:t>
+              </a:r>
+            </a:p>
+            <a:p>
+              <a:pPr algn="ctr"/>
+              <a:endParaRPr lang="en-NL" sz="1000" dirty="0">
                 <a:solidFill>
                   <a:schemeClr val="tx1"/>
                 </a:solidFill>
-              </a:rPr>
-              <a:t>SH Assignament</a:t>
-            </a:r>
-          </a:p>
-          <a:p>
-            <a:pPr algn="ctr"/>
-            <a:endParaRPr lang="en-NL" sz="1000" dirty="0">
-              <a:solidFill>
-                <a:schemeClr val="tx1"/>
-              </a:solidFill>
-            </a:endParaRPr>
-          </a:p>
-          <a:p>
-            <a:pPr algn="ctr"/>
-            <a:r>
-              <a:rPr lang="en-NL" sz="1000" dirty="0">
+              </a:endParaRPr>
+            </a:p>
+            <a:p>
+              <a:pPr algn="ctr"/>
+              <a:r>
+                <a:rPr lang="en-NL" sz="1000" dirty="0">
+                  <a:solidFill>
+                    <a:schemeClr val="tx1"/>
+                  </a:solidFill>
+                </a:rPr>
+                <a:t>Project Registration</a:t>
+              </a:r>
+            </a:p>
+            <a:p>
+              <a:pPr algn="ctr"/>
+              <a:endParaRPr lang="en-NL" sz="1000" dirty="0">
                 <a:solidFill>
                   <a:schemeClr val="tx1"/>
                 </a:solidFill>
-              </a:rPr>
-              <a:t>Administration Setup</a:t>
-            </a:r>
-          </a:p>
-          <a:p>
-            <a:pPr algn="ctr"/>
-            <a:endParaRPr lang="en-NL" sz="1000" dirty="0">
-              <a:solidFill>
-                <a:schemeClr val="tx1"/>
-              </a:solidFill>
-            </a:endParaRPr>
-          </a:p>
-          <a:p>
-            <a:pPr algn="ctr"/>
-            <a:r>
-              <a:rPr lang="en-NL" sz="1000" dirty="0">
+              </a:endParaRPr>
+            </a:p>
+            <a:p>
+              <a:pPr algn="ctr"/>
+              <a:r>
+                <a:rPr lang="en-NL" sz="1000" dirty="0">
+                  <a:solidFill>
+                    <a:schemeClr val="tx1"/>
+                  </a:solidFill>
+                </a:rPr>
+                <a:t>Project Staffing</a:t>
+              </a:r>
+            </a:p>
+            <a:p>
+              <a:pPr algn="ctr"/>
+              <a:endParaRPr lang="en-NL" sz="1000" dirty="0">
                 <a:solidFill>
                   <a:schemeClr val="tx1"/>
                 </a:solidFill>
-              </a:rPr>
-              <a:t>Project Staffing</a:t>
-            </a:r>
-          </a:p>
-          <a:p>
-            <a:pPr algn="ctr"/>
-            <a:endParaRPr lang="en-NL" sz="1000" dirty="0">
-              <a:solidFill>
-                <a:schemeClr val="tx1"/>
-              </a:solidFill>
-            </a:endParaRPr>
-          </a:p>
-          <a:p>
-            <a:pPr algn="ctr"/>
-            <a:r>
-              <a:rPr lang="en-NL" sz="1000" dirty="0">
+              </a:endParaRPr>
+            </a:p>
+            <a:p>
+              <a:pPr algn="ctr"/>
+              <a:r>
+                <a:rPr lang="en-NL" sz="1000" dirty="0">
+                  <a:solidFill>
+                    <a:schemeClr val="tx1"/>
+                  </a:solidFill>
+                </a:rPr>
+                <a:t>Administrative Kick-off Meeting</a:t>
+              </a:r>
+            </a:p>
+            <a:p>
+              <a:pPr algn="ctr"/>
+              <a:endParaRPr lang="en-NL" sz="1000" dirty="0">
                 <a:solidFill>
                   <a:schemeClr val="tx1"/>
                 </a:solidFill>
-              </a:rPr>
-              <a:t>Administrative Kick-off Meeting</a:t>
-            </a:r>
-          </a:p>
-          <a:p>
-            <a:pPr algn="ctr"/>
-            <a:endParaRPr lang="en-NL" sz="1000" dirty="0">
-              <a:solidFill>
-                <a:schemeClr val="tx1"/>
-              </a:solidFill>
-            </a:endParaRPr>
-          </a:p>
-          <a:p>
-            <a:pPr algn="ctr"/>
-            <a:r>
-              <a:rPr lang="en-NL" sz="1000" dirty="0">
+              </a:endParaRPr>
+            </a:p>
+            <a:p>
+              <a:pPr algn="ctr"/>
+              <a:r>
+                <a:rPr lang="en-NL" sz="1000" dirty="0">
+                  <a:solidFill>
+                    <a:schemeClr val="tx1"/>
+                  </a:solidFill>
+                </a:rPr>
+                <a:t>Kick-off Meeting</a:t>
+              </a:r>
+            </a:p>
+            <a:p>
+              <a:pPr algn="ctr"/>
+              <a:endParaRPr lang="en-NL" sz="1000" dirty="0">
                 <a:solidFill>
                   <a:schemeClr val="tx1"/>
                 </a:solidFill>
-              </a:rPr>
-              <a:t>Kick-off Meeting</a:t>
-            </a:r>
-          </a:p>
-          <a:p>
-            <a:pPr algn="ctr"/>
-            <a:endParaRPr lang="en-NL" sz="1000" dirty="0">
-              <a:solidFill>
-                <a:schemeClr val="tx1"/>
-              </a:solidFill>
-            </a:endParaRPr>
-          </a:p>
-          <a:p>
-            <a:pPr algn="ctr"/>
-            <a:r>
-              <a:rPr lang="en-NL" sz="1000" dirty="0">
+              </a:endParaRPr>
+            </a:p>
+            <a:p>
+              <a:pPr algn="ctr"/>
+              <a:r>
+                <a:rPr lang="en-NL" sz="1000" dirty="0">
+                  <a:solidFill>
+                    <a:schemeClr val="tx1"/>
+                  </a:solidFill>
+                </a:rPr>
+                <a:t>Legal Aggrements</a:t>
+              </a:r>
+            </a:p>
+            <a:p>
+              <a:pPr algn="ctr"/>
+              <a:endParaRPr lang="en-NL" sz="1000" dirty="0">
                 <a:solidFill>
                   <a:schemeClr val="tx1"/>
                 </a:solidFill>
-              </a:rPr>
-              <a:t>Legal Aggrements</a:t>
-            </a:r>
-          </a:p>
-          <a:p>
-            <a:pPr algn="ctr"/>
-            <a:endParaRPr lang="en-NL" sz="1000" dirty="0">
-              <a:solidFill>
-                <a:schemeClr val="tx1"/>
-              </a:solidFill>
-            </a:endParaRPr>
-          </a:p>
-          <a:p>
-            <a:pPr algn="ctr"/>
-            <a:r>
-              <a:rPr lang="en-NL" sz="1000" dirty="0">
-                <a:solidFill>
-                  <a:schemeClr val="tx1"/>
-                </a:solidFill>
-              </a:rPr>
-              <a:t>Technology Plan</a:t>
-            </a:r>
-          </a:p>
-        </p:txBody>
-      </p:sp>
-      <p:pic>
-        <p:nvPicPr>
-          <p:cNvPr id="4" name="Picture 3">
-            <a:extLst>
-              <a:ext uri="{FF2B5EF4-FFF2-40B4-BE49-F238E27FC236}">
-                <a16:creationId xmlns:a16="http://schemas.microsoft.com/office/drawing/2014/main" id="{282B2352-F630-1E98-214C-C2CE9CFE3493}"/>
-              </a:ext>
-            </a:extLst>
-          </p:cNvPr>
-          <p:cNvPicPr>
-            <a:picLocks noChangeAspect="1"/>
-          </p:cNvPicPr>
-          <p:nvPr/>
-        </p:nvPicPr>
-        <p:blipFill>
-          <a:blip r:embed="rId2"/>
-          <a:stretch>
-            <a:fillRect/>
-          </a:stretch>
-        </p:blipFill>
-        <p:spPr>
-          <a:xfrm>
-            <a:off x="3612193" y="346654"/>
-            <a:ext cx="4967614" cy="1835022"/>
-          </a:xfrm>
-          <a:prstGeom prst="rect">
-            <a:avLst/>
-          </a:prstGeom>
-        </p:spPr>
-      </p:pic>
+              </a:endParaRPr>
+            </a:p>
+            <a:p>
+              <a:pPr algn="ctr"/>
+              <a:r>
+                <a:rPr lang="en-NL" sz="1000" dirty="0">
+                  <a:solidFill>
+                    <a:schemeClr val="tx1"/>
+                  </a:solidFill>
+                </a:rPr>
+                <a:t>Technology Plan</a:t>
+              </a:r>
+            </a:p>
+          </p:txBody>
+        </p:sp>
+        <p:pic>
+          <p:nvPicPr>
+            <p:cNvPr id="4" name="Picture 3">
+              <a:extLst>
+                <a:ext uri="{FF2B5EF4-FFF2-40B4-BE49-F238E27FC236}">
+                  <a16:creationId xmlns:a16="http://schemas.microsoft.com/office/drawing/2014/main" id="{282B2352-F630-1E98-214C-C2CE9CFE3493}"/>
+                </a:ext>
+              </a:extLst>
+            </p:cNvPr>
+            <p:cNvPicPr>
+              <a:picLocks noChangeAspect="1"/>
+            </p:cNvPicPr>
+            <p:nvPr/>
+          </p:nvPicPr>
+          <p:blipFill>
+            <a:blip r:embed="rId2"/>
+            <a:stretch>
+              <a:fillRect/>
+            </a:stretch>
+          </p:blipFill>
+          <p:spPr>
+            <a:xfrm>
+              <a:off x="3360574" y="341831"/>
+              <a:ext cx="4967614" cy="1835022"/>
+            </a:xfrm>
+            <a:prstGeom prst="rect">
+              <a:avLst/>
+            </a:prstGeom>
+          </p:spPr>
+        </p:pic>
+      </p:grpSp>
     </p:spTree>
     <p:extLst>
       <p:ext uri="{BB962C8B-B14F-4D97-AF65-F5344CB8AC3E}">
@@ -3824,7 +3513,7 @@
 <file path=ppt/theme/theme1.xml><?xml version="1.0" encoding="utf-8"?>
 <a:theme xmlns:a="http://schemas.openxmlformats.org/drawingml/2006/main" name="Office Theme">
   <a:themeElements>
-    <a:clrScheme name="Office">
+    <a:clrScheme name="Office Theme">
       <a:dk1>
         <a:sysClr val="windowText" lastClr="000000"/>
       </a:dk1>
@@ -3862,7 +3551,7 @@
         <a:srgbClr val="96607D"/>
       </a:folHlink>
     </a:clrScheme>
-    <a:fontScheme name="Office">
+    <a:fontScheme name="Office Theme">
       <a:majorFont>
         <a:latin typeface="Aptos Display" panose="02110004020202020204"/>
         <a:ea typeface=""/>
@@ -3968,7 +3657,7 @@
         <a:font script="Tfng" typeface="Ebrima"/>
       </a:minorFont>
     </a:fontScheme>
-    <a:fmtScheme name="Office">
+    <a:fmtScheme name="Office Theme">
       <a:fillStyleLst>
         <a:solidFill>
           <a:schemeClr val="phClr"/>

</xml_diff>